<commit_message>
Adjust key attribute names and values
</commit_message>
<xml_diff>
--- a/spec/InformationStructure/diagrams/InformationStructure.pptx
+++ b/spec/InformationStructure/diagrams/InformationStructure.pptx
@@ -209,7 +209,7 @@
           <a:p>
             <a:fld id="{37CCF725-7468-4D3D-9E24-A16745BBBA77}" type="datetimeFigureOut">
               <a:rPr lang="de-DE" smtClean="0"/>
-              <a:t>16.05.2025</a:t>
+              <a:t>26.06.2025</a:t>
             </a:fld>
             <a:endParaRPr lang="de-DE"/>
           </a:p>
@@ -607,7 +607,7 @@
           <a:p>
             <a:fld id="{9A2764DB-E7DF-4EA7-A1AF-05A77C280FCA}" type="datetimeFigureOut">
               <a:rPr lang="de-DE" smtClean="0"/>
-              <a:t>16.05.2025</a:t>
+              <a:t>26.06.2025</a:t>
             </a:fld>
             <a:endParaRPr lang="de-DE"/>
           </a:p>
@@ -777,7 +777,7 @@
           <a:p>
             <a:fld id="{9A2764DB-E7DF-4EA7-A1AF-05A77C280FCA}" type="datetimeFigureOut">
               <a:rPr lang="de-DE" smtClean="0"/>
-              <a:t>16.05.2025</a:t>
+              <a:t>26.06.2025</a:t>
             </a:fld>
             <a:endParaRPr lang="de-DE"/>
           </a:p>
@@ -957,7 +957,7 @@
           <a:p>
             <a:fld id="{9A2764DB-E7DF-4EA7-A1AF-05A77C280FCA}" type="datetimeFigureOut">
               <a:rPr lang="de-DE" smtClean="0"/>
-              <a:t>16.05.2025</a:t>
+              <a:t>26.06.2025</a:t>
             </a:fld>
             <a:endParaRPr lang="de-DE"/>
           </a:p>
@@ -1127,7 +1127,7 @@
           <a:p>
             <a:fld id="{9A2764DB-E7DF-4EA7-A1AF-05A77C280FCA}" type="datetimeFigureOut">
               <a:rPr lang="de-DE" smtClean="0"/>
-              <a:t>16.05.2025</a:t>
+              <a:t>26.06.2025</a:t>
             </a:fld>
             <a:endParaRPr lang="de-DE"/>
           </a:p>
@@ -1373,7 +1373,7 @@
           <a:p>
             <a:fld id="{9A2764DB-E7DF-4EA7-A1AF-05A77C280FCA}" type="datetimeFigureOut">
               <a:rPr lang="de-DE" smtClean="0"/>
-              <a:t>16.05.2025</a:t>
+              <a:t>26.06.2025</a:t>
             </a:fld>
             <a:endParaRPr lang="de-DE"/>
           </a:p>
@@ -1605,7 +1605,7 @@
           <a:p>
             <a:fld id="{9A2764DB-E7DF-4EA7-A1AF-05A77C280FCA}" type="datetimeFigureOut">
               <a:rPr lang="de-DE" smtClean="0"/>
-              <a:t>16.05.2025</a:t>
+              <a:t>26.06.2025</a:t>
             </a:fld>
             <a:endParaRPr lang="de-DE"/>
           </a:p>
@@ -1972,7 +1972,7 @@
           <a:p>
             <a:fld id="{9A2764DB-E7DF-4EA7-A1AF-05A77C280FCA}" type="datetimeFigureOut">
               <a:rPr lang="de-DE" smtClean="0"/>
-              <a:t>16.05.2025</a:t>
+              <a:t>26.06.2025</a:t>
             </a:fld>
             <a:endParaRPr lang="de-DE"/>
           </a:p>
@@ -2090,7 +2090,7 @@
           <a:p>
             <a:fld id="{9A2764DB-E7DF-4EA7-A1AF-05A77C280FCA}" type="datetimeFigureOut">
               <a:rPr lang="de-DE" smtClean="0"/>
-              <a:t>16.05.2025</a:t>
+              <a:t>26.06.2025</a:t>
             </a:fld>
             <a:endParaRPr lang="de-DE"/>
           </a:p>
@@ -2185,7 +2185,7 @@
           <a:p>
             <a:fld id="{9A2764DB-E7DF-4EA7-A1AF-05A77C280FCA}" type="datetimeFigureOut">
               <a:rPr lang="de-DE" smtClean="0"/>
-              <a:t>16.05.2025</a:t>
+              <a:t>26.06.2025</a:t>
             </a:fld>
             <a:endParaRPr lang="de-DE"/>
           </a:p>
@@ -2462,7 +2462,7 @@
           <a:p>
             <a:fld id="{9A2764DB-E7DF-4EA7-A1AF-05A77C280FCA}" type="datetimeFigureOut">
               <a:rPr lang="de-DE" smtClean="0"/>
-              <a:t>16.05.2025</a:t>
+              <a:t>26.06.2025</a:t>
             </a:fld>
             <a:endParaRPr lang="de-DE"/>
           </a:p>
@@ -2719,7 +2719,7 @@
           <a:p>
             <a:fld id="{9A2764DB-E7DF-4EA7-A1AF-05A77C280FCA}" type="datetimeFigureOut">
               <a:rPr lang="de-DE" smtClean="0"/>
-              <a:t>16.05.2025</a:t>
+              <a:t>26.06.2025</a:t>
             </a:fld>
             <a:endParaRPr lang="de-DE"/>
           </a:p>
@@ -2932,7 +2932,7 @@
           <a:p>
             <a:fld id="{9A2764DB-E7DF-4EA7-A1AF-05A77C280FCA}" type="datetimeFigureOut">
               <a:rPr lang="de-DE" smtClean="0"/>
-              <a:t>16.05.2025</a:t>
+              <a:t>26.06.2025</a:t>
             </a:fld>
             <a:endParaRPr lang="de-DE"/>
           </a:p>
@@ -4118,37 +4118,52 @@
               <a:defRPr/>
             </a:pPr>
             <a:r>
-              <a:rPr lang="de-DE" sz="800" kern="0">
+              <a:rPr lang="de-DE" sz="800" kern="0" dirty="0" err="1">
                 <a:solidFill>
                   <a:prstClr val="black"/>
                 </a:solidFill>
                 <a:latin typeface="Calibri" panose="020F0502020204030204"/>
               </a:rPr>
-              <a:t>local-id=tcpClient</a:t>
+              <a:t>local-id</a:t>
+            </a:r>
+            <a:r>
+              <a:rPr lang="de-DE" sz="800" kern="0" dirty="0">
+                <a:solidFill>
+                  <a:prstClr val="black"/>
+                </a:solidFill>
+                <a:latin typeface="Calibri" panose="020F0502020204030204"/>
+              </a:rPr>
+              <a:t>=</a:t>
+            </a:r>
+            <a:r>
+              <a:rPr lang="de-DE" sz="800" kern="0" dirty="0" err="1">
+                <a:solidFill>
+                  <a:prstClr val="black"/>
+                </a:solidFill>
+                <a:latin typeface="Calibri" panose="020F0502020204030204"/>
+              </a:rPr>
+              <a:t>tcp</a:t>
+            </a:r>
+            <a:r>
+              <a:rPr lang="de-DE" sz="800" kern="0" dirty="0">
+                <a:solidFill>
+                  <a:prstClr val="black"/>
+                </a:solidFill>
+                <a:latin typeface="Calibri" panose="020F0502020204030204"/>
+              </a:rPr>
+              <a:t>-client</a:t>
             </a:r>
           </a:p>
           <a:p>
             <a:pPr defTabSz="914400"/>
             <a:r>
-              <a:rPr lang="de-DE" sz="800" kern="0">
+              <a:rPr lang="de-DE" sz="800" kern="0" dirty="0" err="1">
                 <a:solidFill>
                   <a:prstClr val="black"/>
                 </a:solidFill>
                 <a:latin typeface="Calibri" panose="020F0502020204030204"/>
               </a:rPr>
               <a:t>remoteIpAddress</a:t>
-            </a:r>
-          </a:p>
-          <a:p>
-            <a:pPr defTabSz="914400"/>
-            <a:r>
-              <a:rPr lang="de-DE" sz="800" kern="0">
-                <a:solidFill>
-                  <a:prstClr val="black"/>
-                </a:solidFill>
-                <a:latin typeface="Calibri" panose="020F0502020204030204"/>
-              </a:rPr>
-              <a:t>remotePort</a:t>
             </a:r>
             <a:endParaRPr lang="de-DE" sz="800" kern="0" dirty="0">
               <a:solidFill>
@@ -4157,6 +4172,24 @@
               <a:latin typeface="Calibri" panose="020F0502020204030204"/>
             </a:endParaRPr>
           </a:p>
+          <a:p>
+            <a:pPr defTabSz="914400"/>
+            <a:r>
+              <a:rPr lang="de-DE" sz="800" kern="0" dirty="0" err="1">
+                <a:solidFill>
+                  <a:prstClr val="black"/>
+                </a:solidFill>
+                <a:latin typeface="Calibri" panose="020F0502020204030204"/>
+              </a:rPr>
+              <a:t>remotePort</a:t>
+            </a:r>
+            <a:endParaRPr lang="de-DE" sz="800" kern="0" dirty="0">
+              <a:solidFill>
+                <a:prstClr val="black"/>
+              </a:solidFill>
+              <a:latin typeface="Calibri" panose="020F0502020204030204"/>
+            </a:endParaRPr>
+          </a:p>
         </p:txBody>
       </p:sp>
       <p:sp>
@@ -4199,13 +4232,40 @@
               <a:defRPr/>
             </a:pPr>
             <a:r>
-              <a:rPr lang="de-DE" sz="800" kern="0">
+              <a:rPr lang="de-DE" sz="800" kern="0" dirty="0" err="1">
                 <a:solidFill>
                   <a:prstClr val="black"/>
                 </a:solidFill>
                 <a:latin typeface="Calibri" panose="020F0502020204030204"/>
               </a:rPr>
-              <a:t>local-id=netconfClient</a:t>
+              <a:t>local-id</a:t>
+            </a:r>
+            <a:r>
+              <a:rPr lang="de-DE" sz="800" kern="0" dirty="0">
+                <a:solidFill>
+                  <a:prstClr val="black"/>
+                </a:solidFill>
+                <a:latin typeface="Calibri" panose="020F0502020204030204"/>
+              </a:rPr>
+              <a:t>=</a:t>
+            </a:r>
+            <a:r>
+              <a:rPr lang="de-DE" sz="800" kern="0" dirty="0" err="1">
+                <a:solidFill>
+                  <a:prstClr val="black"/>
+                </a:solidFill>
+                <a:latin typeface="Calibri" panose="020F0502020204030204"/>
+              </a:rPr>
+              <a:t>netconf</a:t>
+            </a:r>
+            <a:r>
+              <a:rPr lang="de-DE" sz="800" kern="0" dirty="0">
+                <a:solidFill>
+                  <a:prstClr val="black"/>
+                </a:solidFill>
+                <a:latin typeface="Calibri" panose="020F0502020204030204"/>
+              </a:rPr>
+              <a:t>-client</a:t>
             </a:r>
           </a:p>
         </p:txBody>
@@ -4446,19 +4506,46 @@
               <a:defRPr/>
             </a:pPr>
             <a:r>
-              <a:rPr lang="de-DE" sz="800" kern="0">
+              <a:rPr lang="de-DE" sz="800" kern="0" dirty="0" err="1">
                 <a:solidFill>
                   <a:prstClr val="black"/>
                 </a:solidFill>
                 <a:latin typeface="Calibri" panose="020F0502020204030204"/>
               </a:rPr>
-              <a:t>local-id=tcpClient</a:t>
+              <a:t>local-id</a:t>
+            </a:r>
+            <a:r>
+              <a:rPr lang="de-DE" sz="800" kern="0" dirty="0">
+                <a:solidFill>
+                  <a:prstClr val="black"/>
+                </a:solidFill>
+                <a:latin typeface="Calibri" panose="020F0502020204030204"/>
+              </a:rPr>
+              <a:t>=</a:t>
+            </a:r>
+            <a:r>
+              <a:rPr lang="de-DE" sz="800" kern="0" dirty="0" err="1">
+                <a:solidFill>
+                  <a:prstClr val="black"/>
+                </a:solidFill>
+                <a:latin typeface="Calibri" panose="020F0502020204030204"/>
+              </a:rPr>
+              <a:t>tcp</a:t>
+            </a:r>
+            <a:r>
+              <a:rPr lang="de-DE" sz="800" kern="0" dirty="0">
+                <a:solidFill>
+                  <a:prstClr val="black"/>
+                </a:solidFill>
+                <a:latin typeface="Calibri" panose="020F0502020204030204"/>
+              </a:rPr>
+              <a:t>-client</a:t>
             </a:r>
           </a:p>
           <a:p>
             <a:pPr defTabSz="914400"/>
             <a:r>
-              <a:rPr lang="de-DE" sz="800" kern="0">
+              <a:rPr lang="de-DE" sz="800" kern="0" dirty="0" err="1">
                 <a:solidFill>
                   <a:prstClr val="black"/>
                 </a:solidFill>
@@ -4466,11 +4553,17 @@
               </a:rPr>
               <a:t>remoteIpAddress</a:t>
             </a:r>
+            <a:endParaRPr lang="de-DE" sz="800" kern="0" dirty="0">
+              <a:solidFill>
+                <a:prstClr val="black"/>
+              </a:solidFill>
+              <a:latin typeface="Calibri" panose="020F0502020204030204"/>
+            </a:endParaRPr>
           </a:p>
           <a:p>
             <a:pPr defTabSz="914400"/>
             <a:r>
-              <a:rPr lang="de-DE" sz="800" kern="0">
+              <a:rPr lang="de-DE" sz="800" kern="0" dirty="0" err="1">
                 <a:solidFill>
                   <a:prstClr val="black"/>
                 </a:solidFill>
@@ -4649,37 +4742,52 @@
           <a:p>
             <a:pPr defTabSz="914400"/>
             <a:r>
-              <a:rPr lang="de-DE" sz="800" kern="0">
+              <a:rPr lang="de-DE" sz="800" kern="0" dirty="0" err="1">
                 <a:solidFill>
                   <a:prstClr val="black"/>
                 </a:solidFill>
                 <a:latin typeface="Calibri" panose="020F0502020204030204"/>
               </a:rPr>
-              <a:t>local-id=tcpServer</a:t>
+              <a:t>local-id</a:t>
+            </a:r>
+            <a:r>
+              <a:rPr lang="de-DE" sz="800" kern="0" dirty="0">
+                <a:solidFill>
+                  <a:prstClr val="black"/>
+                </a:solidFill>
+                <a:latin typeface="Calibri" panose="020F0502020204030204"/>
+              </a:rPr>
+              <a:t>=</a:t>
+            </a:r>
+            <a:r>
+              <a:rPr lang="de-DE" sz="800" kern="0" dirty="0" err="1">
+                <a:solidFill>
+                  <a:prstClr val="black"/>
+                </a:solidFill>
+                <a:latin typeface="Calibri" panose="020F0502020204030204"/>
+              </a:rPr>
+              <a:t>tcp</a:t>
+            </a:r>
+            <a:r>
+              <a:rPr lang="de-DE" sz="800" kern="0" dirty="0">
+                <a:solidFill>
+                  <a:prstClr val="black"/>
+                </a:solidFill>
+                <a:latin typeface="Calibri" panose="020F0502020204030204"/>
+              </a:rPr>
+              <a:t>-server</a:t>
             </a:r>
           </a:p>
           <a:p>
             <a:pPr defTabSz="914400"/>
             <a:r>
-              <a:rPr lang="de-DE" sz="800" kern="0">
+              <a:rPr lang="de-DE" sz="800" kern="0" dirty="0" err="1">
                 <a:solidFill>
                   <a:prstClr val="black"/>
                 </a:solidFill>
                 <a:latin typeface="Calibri" panose="020F0502020204030204"/>
               </a:rPr>
               <a:t>localIpAddress</a:t>
-            </a:r>
-          </a:p>
-          <a:p>
-            <a:pPr defTabSz="914400"/>
-            <a:r>
-              <a:rPr lang="de-DE" sz="800" kern="0">
-                <a:solidFill>
-                  <a:prstClr val="black"/>
-                </a:solidFill>
-                <a:latin typeface="Calibri" panose="020F0502020204030204"/>
-              </a:rPr>
-              <a:t>localPort</a:t>
             </a:r>
             <a:endParaRPr lang="de-DE" sz="800" kern="0" dirty="0">
               <a:solidFill>
@@ -4688,6 +4796,24 @@
               <a:latin typeface="Calibri" panose="020F0502020204030204"/>
             </a:endParaRPr>
           </a:p>
+          <a:p>
+            <a:pPr defTabSz="914400"/>
+            <a:r>
+              <a:rPr lang="de-DE" sz="800" kern="0" dirty="0" err="1">
+                <a:solidFill>
+                  <a:prstClr val="black"/>
+                </a:solidFill>
+                <a:latin typeface="Calibri" panose="020F0502020204030204"/>
+              </a:rPr>
+              <a:t>localPort</a:t>
+            </a:r>
+            <a:endParaRPr lang="de-DE" sz="800" kern="0" dirty="0">
+              <a:solidFill>
+                <a:prstClr val="black"/>
+              </a:solidFill>
+              <a:latin typeface="Calibri" panose="020F0502020204030204"/>
+            </a:endParaRPr>
+          </a:p>
         </p:txBody>
       </p:sp>
       <p:cxnSp>
@@ -4764,13 +4890,40 @@
           <a:p>
             <a:pPr defTabSz="914400"/>
             <a:r>
-              <a:rPr lang="de-DE" sz="800" kern="0">
+              <a:rPr lang="de-DE" sz="800" kern="0" dirty="0" err="1">
                 <a:solidFill>
                   <a:prstClr val="black"/>
                 </a:solidFill>
                 <a:latin typeface="Calibri" panose="020F0502020204030204"/>
               </a:rPr>
-              <a:t>local-id=netconfServer</a:t>
+              <a:t>local-id</a:t>
+            </a:r>
+            <a:r>
+              <a:rPr lang="de-DE" sz="800" kern="0" dirty="0">
+                <a:solidFill>
+                  <a:prstClr val="black"/>
+                </a:solidFill>
+                <a:latin typeface="Calibri" panose="020F0502020204030204"/>
+              </a:rPr>
+              <a:t>=</a:t>
+            </a:r>
+            <a:r>
+              <a:rPr lang="de-DE" sz="800" kern="0" dirty="0" err="1">
+                <a:solidFill>
+                  <a:prstClr val="black"/>
+                </a:solidFill>
+                <a:latin typeface="Calibri" panose="020F0502020204030204"/>
+              </a:rPr>
+              <a:t>netconf</a:t>
+            </a:r>
+            <a:r>
+              <a:rPr lang="de-DE" sz="800" kern="0" dirty="0">
+                <a:solidFill>
+                  <a:prstClr val="black"/>
+                </a:solidFill>
+                <a:latin typeface="Calibri" panose="020F0502020204030204"/>
+              </a:rPr>
+              <a:t>-server</a:t>
             </a:r>
           </a:p>
         </p:txBody>
@@ -4849,19 +5002,46 @@
           <a:p>
             <a:pPr defTabSz="914400"/>
             <a:r>
-              <a:rPr lang="de-DE" sz="800" kern="0">
+              <a:rPr lang="de-DE" sz="800" kern="0" dirty="0" err="1">
                 <a:solidFill>
                   <a:prstClr val="black"/>
                 </a:solidFill>
                 <a:latin typeface="Calibri" panose="020F0502020204030204"/>
               </a:rPr>
-              <a:t>local-id=snmpClient</a:t>
+              <a:t>local-id</a:t>
+            </a:r>
+            <a:r>
+              <a:rPr lang="de-DE" sz="800" kern="0" dirty="0">
+                <a:solidFill>
+                  <a:prstClr val="black"/>
+                </a:solidFill>
+                <a:latin typeface="Calibri" panose="020F0502020204030204"/>
+              </a:rPr>
+              <a:t>=</a:t>
+            </a:r>
+            <a:r>
+              <a:rPr lang="de-DE" sz="800" kern="0" dirty="0" err="1">
+                <a:solidFill>
+                  <a:prstClr val="black"/>
+                </a:solidFill>
+                <a:latin typeface="Calibri" panose="020F0502020204030204"/>
+              </a:rPr>
+              <a:t>snmp</a:t>
+            </a:r>
+            <a:r>
+              <a:rPr lang="de-DE" sz="800" kern="0" dirty="0">
+                <a:solidFill>
+                  <a:prstClr val="black"/>
+                </a:solidFill>
+                <a:latin typeface="Calibri" panose="020F0502020204030204"/>
+              </a:rPr>
+              <a:t>-client</a:t>
             </a:r>
           </a:p>
           <a:p>
             <a:pPr defTabSz="914400"/>
             <a:r>
-              <a:rPr lang="de-DE" sz="800" kern="0">
+              <a:rPr lang="de-DE" sz="800" kern="0" dirty="0" err="1">
                 <a:solidFill>
                   <a:prstClr val="black"/>
                 </a:solidFill>
@@ -4869,11 +5049,17 @@
               </a:rPr>
               <a:t>mediatorUserName</a:t>
             </a:r>
+            <a:endParaRPr lang="de-DE" sz="800" kern="0" dirty="0">
+              <a:solidFill>
+                <a:prstClr val="black"/>
+              </a:solidFill>
+              <a:latin typeface="Calibri" panose="020F0502020204030204"/>
+            </a:endParaRPr>
           </a:p>
           <a:p>
             <a:pPr defTabSz="914400"/>
             <a:r>
-              <a:rPr lang="de-DE" sz="800" kern="0">
+              <a:rPr lang="de-DE" sz="800" kern="0" dirty="0" err="1">
                 <a:solidFill>
                   <a:prstClr val="black"/>
                 </a:solidFill>
@@ -4881,10 +5067,16 @@
               </a:rPr>
               <a:t>mediatorUserPassword</a:t>
             </a:r>
+            <a:endParaRPr lang="de-DE" sz="800" kern="0" dirty="0">
+              <a:solidFill>
+                <a:prstClr val="black"/>
+              </a:solidFill>
+              <a:latin typeface="Calibri" panose="020F0502020204030204"/>
+            </a:endParaRPr>
           </a:p>
           <a:p>
             <a:pPr defTabSz="914400"/>
-            <a:endParaRPr lang="de-DE" sz="800" kern="0">
+            <a:endParaRPr lang="de-DE" sz="800" kern="0" dirty="0">
               <a:solidFill>
                 <a:prstClr val="black"/>
               </a:solidFill>
@@ -5214,86 +5406,13 @@
           <a:p>
             <a:pPr defTabSz="914400"/>
             <a:r>
-              <a:rPr lang="de-DE" sz="800" kern="0">
+              <a:rPr lang="de-DE" sz="800" kern="0" dirty="0" err="1">
                 <a:solidFill>
                   <a:prstClr val="black"/>
                 </a:solidFill>
                 <a:latin typeface="Calibri" panose="020F0502020204030204"/>
               </a:rPr>
-              <a:t>local-id=mimOperationServer[N]</a:t>
-            </a:r>
-          </a:p>
-          <a:p>
-            <a:pPr defTabSz="914400"/>
-            <a:r>
-              <a:rPr lang="de-DE" sz="800" kern="0">
-                <a:solidFill>
-                  <a:prstClr val="black"/>
-                </a:solidFill>
-                <a:latin typeface="Calibri" panose="020F0502020204030204"/>
-              </a:rPr>
-              <a:t>operationName</a:t>
-            </a:r>
-          </a:p>
-        </p:txBody>
-      </p:sp>
-      <p:sp>
-        <p:nvSpPr>
-          <p:cNvPr id="154" name="Rechteck 153">
-            <a:extLst>
-              <a:ext uri="{FF2B5EF4-FFF2-40B4-BE49-F238E27FC236}">
-                <a16:creationId xmlns:a16="http://schemas.microsoft.com/office/drawing/2014/main" id="{603038BB-B38F-04CB-CE97-EB1D3BC5A2ED}"/>
-              </a:ext>
-            </a:extLst>
-          </p:cNvPr>
-          <p:cNvSpPr/>
-          <p:nvPr/>
-        </p:nvSpPr>
-        <p:spPr>
-          <a:xfrm>
-            <a:off x="6851185" y="10590534"/>
-            <a:ext cx="1815783" cy="445572"/>
-          </a:xfrm>
-          <a:prstGeom prst="rect">
-            <a:avLst/>
-          </a:prstGeom>
-          <a:solidFill>
-            <a:sysClr val="window" lastClr="FFFFFF"/>
-          </a:solidFill>
-          <a:ln w="12700" cap="flat" cmpd="sng" algn="ctr">
-            <a:solidFill>
-              <a:srgbClr val="A5A5A5"/>
-            </a:solidFill>
-            <a:prstDash val="solid"/>
-            <a:miter lim="800000"/>
-          </a:ln>
-          <a:effectLst/>
-        </p:spPr>
-        <p:txBody>
-          <a:bodyPr lIns="36000" tIns="36000" rIns="36000" bIns="36000" rtlCol="0" anchor="t"/>
-          <a:lstStyle/>
-          <a:p>
-            <a:pPr defTabSz="914400"/>
-            <a:r>
-              <a:rPr lang="de-DE" sz="800" kern="0">
-                <a:solidFill>
-                  <a:prstClr val="black"/>
-                </a:solidFill>
-                <a:latin typeface="Calibri" panose="020F0502020204030204"/>
-              </a:rPr>
-              <a:t>local-id=mimTcpServer</a:t>
-            </a:r>
-          </a:p>
-          <a:p>
-            <a:pPr defTabSz="914400"/>
-            <a:r>
-              <a:rPr lang="de-DE" sz="800" kern="0">
-                <a:solidFill>
-                  <a:prstClr val="black"/>
-                </a:solidFill>
-                <a:latin typeface="Calibri" panose="020F0502020204030204"/>
-              </a:rPr>
-              <a:t>localIpAddress</a:t>
+              <a:t>local-id</a:t>
             </a:r>
             <a:endParaRPr lang="de-DE" sz="800" kern="0" dirty="0">
               <a:solidFill>
@@ -5305,13 +5424,13 @@
           <a:p>
             <a:pPr defTabSz="914400"/>
             <a:r>
-              <a:rPr lang="de-DE" sz="800" kern="0">
+              <a:rPr lang="de-DE" sz="800" kern="0" dirty="0" err="1">
                 <a:solidFill>
                   <a:prstClr val="black"/>
                 </a:solidFill>
                 <a:latin typeface="Calibri" panose="020F0502020204030204"/>
               </a:rPr>
-              <a:t>localPort</a:t>
+              <a:t>operationName</a:t>
             </a:r>
             <a:endParaRPr lang="de-DE" sz="800" kern="0" dirty="0">
               <a:solidFill>
@@ -5322,6 +5441,118 @@
           </a:p>
         </p:txBody>
       </p:sp>
+      <p:sp>
+        <p:nvSpPr>
+          <p:cNvPr id="154" name="Rechteck 153">
+            <a:extLst>
+              <a:ext uri="{FF2B5EF4-FFF2-40B4-BE49-F238E27FC236}">
+                <a16:creationId xmlns:a16="http://schemas.microsoft.com/office/drawing/2014/main" id="{603038BB-B38F-04CB-CE97-EB1D3BC5A2ED}"/>
+              </a:ext>
+            </a:extLst>
+          </p:cNvPr>
+          <p:cNvSpPr/>
+          <p:nvPr/>
+        </p:nvSpPr>
+        <p:spPr>
+          <a:xfrm>
+            <a:off x="6851185" y="10590534"/>
+            <a:ext cx="1815783" cy="445572"/>
+          </a:xfrm>
+          <a:prstGeom prst="rect">
+            <a:avLst/>
+          </a:prstGeom>
+          <a:solidFill>
+            <a:sysClr val="window" lastClr="FFFFFF"/>
+          </a:solidFill>
+          <a:ln w="12700" cap="flat" cmpd="sng" algn="ctr">
+            <a:solidFill>
+              <a:srgbClr val="A5A5A5"/>
+            </a:solidFill>
+            <a:prstDash val="solid"/>
+            <a:miter lim="800000"/>
+          </a:ln>
+          <a:effectLst/>
+        </p:spPr>
+        <p:txBody>
+          <a:bodyPr lIns="36000" tIns="36000" rIns="36000" bIns="36000" rtlCol="0" anchor="t"/>
+          <a:lstStyle/>
+          <a:p>
+            <a:pPr defTabSz="914400"/>
+            <a:r>
+              <a:rPr lang="de-DE" sz="800" kern="0" dirty="0" err="1">
+                <a:solidFill>
+                  <a:prstClr val="black"/>
+                </a:solidFill>
+                <a:latin typeface="Calibri" panose="020F0502020204030204"/>
+              </a:rPr>
+              <a:t>local-id</a:t>
+            </a:r>
+            <a:r>
+              <a:rPr lang="de-DE" sz="800" kern="0" dirty="0">
+                <a:solidFill>
+                  <a:prstClr val="black"/>
+                </a:solidFill>
+                <a:latin typeface="Calibri" panose="020F0502020204030204"/>
+              </a:rPr>
+              <a:t>=</a:t>
+            </a:r>
+            <a:r>
+              <a:rPr lang="de-DE" sz="800" kern="0" dirty="0" err="1">
+                <a:solidFill>
+                  <a:prstClr val="black"/>
+                </a:solidFill>
+                <a:latin typeface="Calibri" panose="020F0502020204030204"/>
+              </a:rPr>
+              <a:t>tcp</a:t>
+            </a:r>
+            <a:r>
+              <a:rPr lang="de-DE" sz="800" kern="0" dirty="0">
+                <a:solidFill>
+                  <a:prstClr val="black"/>
+                </a:solidFill>
+                <a:latin typeface="Calibri" panose="020F0502020204030204"/>
+              </a:rPr>
+              <a:t>-server</a:t>
+            </a:r>
+          </a:p>
+          <a:p>
+            <a:pPr defTabSz="914400"/>
+            <a:r>
+              <a:rPr lang="de-DE" sz="800" kern="0" dirty="0" err="1">
+                <a:solidFill>
+                  <a:prstClr val="black"/>
+                </a:solidFill>
+                <a:latin typeface="Calibri" panose="020F0502020204030204"/>
+              </a:rPr>
+              <a:t>localIpAddress</a:t>
+            </a:r>
+            <a:endParaRPr lang="de-DE" sz="800" kern="0" dirty="0">
+              <a:solidFill>
+                <a:prstClr val="black"/>
+              </a:solidFill>
+              <a:latin typeface="Calibri" panose="020F0502020204030204"/>
+            </a:endParaRPr>
+          </a:p>
+          <a:p>
+            <a:pPr defTabSz="914400"/>
+            <a:r>
+              <a:rPr lang="de-DE" sz="800" kern="0" dirty="0" err="1">
+                <a:solidFill>
+                  <a:prstClr val="black"/>
+                </a:solidFill>
+                <a:latin typeface="Calibri" panose="020F0502020204030204"/>
+              </a:rPr>
+              <a:t>localPort</a:t>
+            </a:r>
+            <a:endParaRPr lang="de-DE" sz="800" kern="0" dirty="0">
+              <a:solidFill>
+                <a:prstClr val="black"/>
+              </a:solidFill>
+              <a:latin typeface="Calibri" panose="020F0502020204030204"/>
+            </a:endParaRPr>
+          </a:p>
+        </p:txBody>
+      </p:sp>
       <p:cxnSp>
         <p:nvCxnSpPr>
           <p:cNvPr id="155" name="Gerade Verbindung mit Pfeil 154">
@@ -5396,19 +5627,28 @@
           <a:p>
             <a:pPr defTabSz="914400"/>
             <a:r>
-              <a:rPr lang="de-DE" sz="800" kern="0">
+              <a:rPr lang="de-DE" sz="800" kern="0" dirty="0" err="1">
                 <a:solidFill>
                   <a:prstClr val="black"/>
                 </a:solidFill>
                 <a:latin typeface="Calibri" panose="020F0502020204030204"/>
               </a:rPr>
-              <a:t>local-id=mimHttpServer</a:t>
+              <a:t>local-id</a:t>
+            </a:r>
+            <a:r>
+              <a:rPr lang="de-DE" sz="800" kern="0" dirty="0">
+                <a:solidFill>
+                  <a:prstClr val="black"/>
+                </a:solidFill>
+                <a:latin typeface="Calibri" panose="020F0502020204030204"/>
+              </a:rPr>
+              <a:t>=http-server</a:t>
             </a:r>
           </a:p>
           <a:p>
             <a:pPr defTabSz="914400"/>
             <a:r>
-              <a:rPr lang="de-DE" sz="800" kern="0">
+              <a:rPr lang="de-DE" sz="800" kern="0" dirty="0" err="1">
                 <a:solidFill>
                   <a:prstClr val="black"/>
                 </a:solidFill>
@@ -5416,11 +5656,17 @@
               </a:rPr>
               <a:t>mediatorUserName</a:t>
             </a:r>
+            <a:endParaRPr lang="de-DE" sz="800" kern="0" dirty="0">
+              <a:solidFill>
+                <a:prstClr val="black"/>
+              </a:solidFill>
+              <a:latin typeface="Calibri" panose="020F0502020204030204"/>
+            </a:endParaRPr>
           </a:p>
           <a:p>
             <a:pPr defTabSz="914400"/>
             <a:r>
-              <a:rPr lang="de-DE" sz="800" kern="0">
+              <a:rPr lang="de-DE" sz="800" kern="0" dirty="0" err="1">
                 <a:solidFill>
                   <a:prstClr val="black"/>
                 </a:solidFill>
@@ -5428,6 +5674,12 @@
               </a:rPr>
               <a:t>mediatorUserPassword</a:t>
             </a:r>
+            <a:endParaRPr lang="de-DE" sz="800" kern="0" dirty="0">
+              <a:solidFill>
+                <a:prstClr val="black"/>
+              </a:solidFill>
+              <a:latin typeface="Calibri" panose="020F0502020204030204"/>
+            </a:endParaRPr>
           </a:p>
         </p:txBody>
       </p:sp>
@@ -5541,42 +5793,117 @@
           <a:p>
             <a:pPr defTabSz="914400"/>
             <a:r>
-              <a:rPr lang="de-DE" sz="800" kern="0">
+              <a:rPr lang="de-DE" sz="800" kern="0" dirty="0">
                 <a:solidFill>
                   <a:prstClr val="black"/>
                 </a:solidFill>
                 <a:latin typeface="Calibri" panose="020F0502020204030204"/>
               </a:rPr>
-              <a:t>local-id=[mediatorVmName]</a:t>
+              <a:t>element-name=[</a:t>
+            </a:r>
+            <a:r>
+              <a:rPr lang="de-DE" sz="800" kern="0" dirty="0" err="1">
+                <a:solidFill>
+                  <a:prstClr val="black"/>
+                </a:solidFill>
+                <a:latin typeface="Calibri" panose="020F0502020204030204"/>
+              </a:rPr>
+              <a:t>mediatorVmName</a:t>
+            </a:r>
+            <a:r>
+              <a:rPr lang="de-DE" sz="800" kern="0" dirty="0">
+                <a:solidFill>
+                  <a:prstClr val="black"/>
+                </a:solidFill>
+                <a:latin typeface="Calibri" panose="020F0502020204030204"/>
+              </a:rPr>
+              <a:t>]</a:t>
             </a:r>
           </a:p>
           <a:p>
             <a:pPr defTabSz="914400"/>
             <a:r>
-              <a:rPr lang="de-DE" sz="800" kern="0">
+              <a:rPr lang="de-DE" sz="800" kern="0" dirty="0" err="1">
                 <a:solidFill>
                   <a:prstClr val="black"/>
                 </a:solidFill>
                 <a:latin typeface="Calibri" panose="020F0502020204030204"/>
               </a:rPr>
-              <a:t>category=mediatorVm</a:t>
-            </a:r>
+              <a:t>category</a:t>
+            </a:r>
+            <a:r>
+              <a:rPr lang="de-DE" sz="800" kern="0" dirty="0">
+                <a:solidFill>
+                  <a:prstClr val="black"/>
+                </a:solidFill>
+                <a:latin typeface="Calibri" panose="020F0502020204030204"/>
+              </a:rPr>
+              <a:t>=</a:t>
+            </a:r>
+            <a:r>
+              <a:rPr lang="de-DE" sz="800" kern="0" dirty="0" err="1">
+                <a:solidFill>
+                  <a:prstClr val="black"/>
+                </a:solidFill>
+                <a:latin typeface="Calibri" panose="020F0502020204030204"/>
+              </a:rPr>
+              <a:t>mediatorVm</a:t>
+            </a:r>
+            <a:endParaRPr lang="de-DE" sz="800" kern="0" dirty="0">
+              <a:solidFill>
+                <a:prstClr val="black"/>
+              </a:solidFill>
+              <a:latin typeface="Calibri" panose="020F0502020204030204"/>
+            </a:endParaRPr>
           </a:p>
           <a:p>
             <a:pPr defTabSz="914400"/>
             <a:r>
-              <a:rPr lang="de-DE" sz="800" kern="0">
+              <a:rPr lang="de-DE" sz="800" kern="0" dirty="0">
                 <a:solidFill>
                   <a:prstClr val="black"/>
                 </a:solidFill>
                 <a:latin typeface="Calibri" panose="020F0502020204030204"/>
               </a:rPr>
-              <a:t>_template= mediatorVmTemplateName</a:t>
-            </a:r>
+              <a:t>_</a:t>
+            </a:r>
+            <a:r>
+              <a:rPr lang="de-DE" sz="800" kern="0" dirty="0" err="1">
+                <a:solidFill>
+                  <a:prstClr val="black"/>
+                </a:solidFill>
+                <a:latin typeface="Calibri" panose="020F0502020204030204"/>
+              </a:rPr>
+              <a:t>template</a:t>
+            </a:r>
+            <a:r>
+              <a:rPr lang="de-DE" sz="800" kern="0" dirty="0">
+                <a:solidFill>
+                  <a:prstClr val="black"/>
+                </a:solidFill>
+                <a:latin typeface="Calibri" panose="020F0502020204030204"/>
+              </a:rPr>
+              <a:t>= </a:t>
+            </a:r>
+            <a:r>
+              <a:rPr lang="de-DE" sz="800" kern="0" dirty="0" err="1">
+                <a:solidFill>
+                  <a:prstClr val="black"/>
+                </a:solidFill>
+                <a:latin typeface="Calibri" panose="020F0502020204030204"/>
+              </a:rPr>
+              <a:t>mediatorVmTemplateName</a:t>
+            </a:r>
+            <a:endParaRPr lang="de-DE" sz="800" kern="0" dirty="0">
+              <a:solidFill>
+                <a:prstClr val="black"/>
+              </a:solidFill>
+              <a:latin typeface="Calibri" panose="020F0502020204030204"/>
+            </a:endParaRPr>
           </a:p>
           <a:p>
             <a:pPr defTabSz="914400"/>
-            <a:endParaRPr lang="de-DE" sz="800" kern="0">
+            <a:endParaRPr lang="de-DE" sz="800" kern="0" dirty="0">
               <a:solidFill>
                 <a:prstClr val="black"/>
               </a:solidFill>
@@ -5880,37 +6207,52 @@
           <a:p>
             <a:pPr defTabSz="914400"/>
             <a:r>
-              <a:rPr lang="de-DE" sz="800" kern="0">
+              <a:rPr lang="de-DE" sz="800" kern="0" dirty="0" err="1">
                 <a:solidFill>
                   <a:prstClr val="black"/>
                 </a:solidFill>
                 <a:latin typeface="Calibri" panose="020F0502020204030204"/>
               </a:rPr>
-              <a:t>local-id=tcpServer</a:t>
+              <a:t>local-id</a:t>
+            </a:r>
+            <a:r>
+              <a:rPr lang="de-DE" sz="800" kern="0" dirty="0">
+                <a:solidFill>
+                  <a:prstClr val="black"/>
+                </a:solidFill>
+                <a:latin typeface="Calibri" panose="020F0502020204030204"/>
+              </a:rPr>
+              <a:t>=</a:t>
+            </a:r>
+            <a:r>
+              <a:rPr lang="de-DE" sz="800" kern="0" dirty="0" err="1">
+                <a:solidFill>
+                  <a:prstClr val="black"/>
+                </a:solidFill>
+                <a:latin typeface="Calibri" panose="020F0502020204030204"/>
+              </a:rPr>
+              <a:t>tcp</a:t>
+            </a:r>
+            <a:r>
+              <a:rPr lang="de-DE" sz="800" kern="0" dirty="0">
+                <a:solidFill>
+                  <a:prstClr val="black"/>
+                </a:solidFill>
+                <a:latin typeface="Calibri" panose="020F0502020204030204"/>
+              </a:rPr>
+              <a:t>-server</a:t>
             </a:r>
           </a:p>
           <a:p>
             <a:pPr defTabSz="914400"/>
             <a:r>
-              <a:rPr lang="de-DE" sz="800" kern="0">
+              <a:rPr lang="de-DE" sz="800" kern="0" dirty="0" err="1">
                 <a:solidFill>
                   <a:prstClr val="black"/>
                 </a:solidFill>
                 <a:latin typeface="Calibri" panose="020F0502020204030204"/>
               </a:rPr>
               <a:t>localIpAddress</a:t>
-            </a:r>
-          </a:p>
-          <a:p>
-            <a:pPr defTabSz="914400"/>
-            <a:r>
-              <a:rPr lang="de-DE" sz="800" kern="0">
-                <a:solidFill>
-                  <a:prstClr val="black"/>
-                </a:solidFill>
-                <a:latin typeface="Calibri" panose="020F0502020204030204"/>
-              </a:rPr>
-              <a:t>localPort</a:t>
             </a:r>
             <a:endParaRPr lang="de-DE" sz="800" kern="0" dirty="0">
               <a:solidFill>
@@ -5919,115 +6261,16 @@
               <a:latin typeface="Calibri" panose="020F0502020204030204"/>
             </a:endParaRPr>
           </a:p>
-        </p:txBody>
-      </p:sp>
-      <p:cxnSp>
-        <p:nvCxnSpPr>
-          <p:cNvPr id="231" name="Gerade Verbindung mit Pfeil 230">
-            <a:extLst>
-              <a:ext uri="{FF2B5EF4-FFF2-40B4-BE49-F238E27FC236}">
-                <a16:creationId xmlns:a16="http://schemas.microsoft.com/office/drawing/2014/main" id="{E2AA1378-2624-C82E-46F5-DAE3598C92F9}"/>
-              </a:ext>
-            </a:extLst>
-          </p:cNvPr>
-          <p:cNvCxnSpPr>
-            <a:cxnSpLocks/>
-            <a:stCxn id="222" idx="1"/>
-            <a:endCxn id="230" idx="3"/>
-          </p:cNvCxnSpPr>
-          <p:nvPr/>
-        </p:nvCxnSpPr>
-        <p:spPr>
-          <a:xfrm flipH="1">
-            <a:off x="18992101" y="13711746"/>
-            <a:ext cx="573605" cy="9241"/>
-          </a:xfrm>
-          <a:prstGeom prst="straightConnector1">
-            <a:avLst/>
-          </a:prstGeom>
-          <a:noFill/>
-          <a:ln w="6350" cap="flat" cmpd="sng" algn="ctr">
-            <a:solidFill>
-              <a:srgbClr val="5B9BD5"/>
-            </a:solidFill>
-            <a:prstDash val="solid"/>
-            <a:miter lim="800000"/>
-            <a:tailEnd type="triangle"/>
-          </a:ln>
-          <a:effectLst/>
-        </p:spPr>
-      </p:cxnSp>
-      <p:sp>
-        <p:nvSpPr>
-          <p:cNvPr id="232" name="Rechteck 231">
-            <a:extLst>
-              <a:ext uri="{FF2B5EF4-FFF2-40B4-BE49-F238E27FC236}">
-                <a16:creationId xmlns:a16="http://schemas.microsoft.com/office/drawing/2014/main" id="{D24AFCEE-3415-2633-C02F-42F690432881}"/>
-              </a:ext>
-            </a:extLst>
-          </p:cNvPr>
-          <p:cNvSpPr/>
-          <p:nvPr/>
-        </p:nvSpPr>
-        <p:spPr>
-          <a:xfrm>
-            <a:off x="17566269" y="12736077"/>
-            <a:ext cx="1425832" cy="479569"/>
-          </a:xfrm>
-          <a:prstGeom prst="rect">
-            <a:avLst/>
-          </a:prstGeom>
-          <a:solidFill>
-            <a:sysClr val="window" lastClr="FFFFFF"/>
-          </a:solidFill>
-          <a:ln w="12700" cap="flat" cmpd="sng" algn="ctr">
-            <a:solidFill>
-              <a:srgbClr val="A5A5A5"/>
-            </a:solidFill>
-            <a:prstDash val="solid"/>
-            <a:miter lim="800000"/>
-          </a:ln>
-          <a:effectLst/>
-        </p:spPr>
-        <p:txBody>
-          <a:bodyPr lIns="36000" tIns="36000" rIns="36000" bIns="36000" rtlCol="0" anchor="t"/>
-          <a:lstStyle/>
-          <a:p>
-            <a:pPr defTabSz="914400">
-              <a:defRPr/>
-            </a:pPr>
-            <a:r>
-              <a:rPr lang="de-DE" sz="800" kern="0">
+          <a:p>
+            <a:pPr defTabSz="914400"/>
+            <a:r>
+              <a:rPr lang="de-DE" sz="800" kern="0" dirty="0" err="1">
                 <a:solidFill>
                   <a:prstClr val="black"/>
                 </a:solidFill>
                 <a:latin typeface="Calibri" panose="020F0502020204030204"/>
               </a:rPr>
-              <a:t>local-id=[mediatorUserName]</a:t>
-            </a:r>
-          </a:p>
-          <a:p>
-            <a:pPr defTabSz="914400"/>
-            <a:r>
-              <a:rPr lang="de-DE" sz="800" kern="0">
-                <a:solidFill>
-                  <a:prstClr val="black"/>
-                </a:solidFill>
-                <a:latin typeface="Calibri" panose="020F0502020204030204"/>
-              </a:rPr>
-              <a:t>mediatorUserName</a:t>
-            </a:r>
-          </a:p>
-          <a:p>
-            <a:pPr defTabSz="914400"/>
-            <a:r>
-              <a:rPr lang="de-DE" sz="800" kern="0">
-                <a:solidFill>
-                  <a:prstClr val="black"/>
-                </a:solidFill>
-                <a:latin typeface="Calibri" panose="020F0502020204030204"/>
-              </a:rPr>
-              <a:t>mediatorUserPassword</a:t>
+              <a:t>localPort</a:t>
             </a:r>
             <a:endParaRPr lang="de-DE" sz="800" kern="0" dirty="0">
               <a:solidFill>
@@ -6040,6 +6283,123 @@
       </p:sp>
       <p:cxnSp>
         <p:nvCxnSpPr>
+          <p:cNvPr id="231" name="Gerade Verbindung mit Pfeil 230">
+            <a:extLst>
+              <a:ext uri="{FF2B5EF4-FFF2-40B4-BE49-F238E27FC236}">
+                <a16:creationId xmlns:a16="http://schemas.microsoft.com/office/drawing/2014/main" id="{E2AA1378-2624-C82E-46F5-DAE3598C92F9}"/>
+              </a:ext>
+            </a:extLst>
+          </p:cNvPr>
+          <p:cNvCxnSpPr>
+            <a:cxnSpLocks/>
+            <a:stCxn id="222" idx="1"/>
+            <a:endCxn id="230" idx="3"/>
+          </p:cNvCxnSpPr>
+          <p:nvPr/>
+        </p:nvCxnSpPr>
+        <p:spPr>
+          <a:xfrm flipH="1">
+            <a:off x="18992101" y="13711746"/>
+            <a:ext cx="573605" cy="9241"/>
+          </a:xfrm>
+          <a:prstGeom prst="straightConnector1">
+            <a:avLst/>
+          </a:prstGeom>
+          <a:noFill/>
+          <a:ln w="6350" cap="flat" cmpd="sng" algn="ctr">
+            <a:solidFill>
+              <a:srgbClr val="5B9BD5"/>
+            </a:solidFill>
+            <a:prstDash val="solid"/>
+            <a:miter lim="800000"/>
+            <a:tailEnd type="triangle"/>
+          </a:ln>
+          <a:effectLst/>
+        </p:spPr>
+      </p:cxnSp>
+      <p:sp>
+        <p:nvSpPr>
+          <p:cNvPr id="232" name="Rechteck 231">
+            <a:extLst>
+              <a:ext uri="{FF2B5EF4-FFF2-40B4-BE49-F238E27FC236}">
+                <a16:creationId xmlns:a16="http://schemas.microsoft.com/office/drawing/2014/main" id="{D24AFCEE-3415-2633-C02F-42F690432881}"/>
+              </a:ext>
+            </a:extLst>
+          </p:cNvPr>
+          <p:cNvSpPr/>
+          <p:nvPr/>
+        </p:nvSpPr>
+        <p:spPr>
+          <a:xfrm>
+            <a:off x="17566269" y="12736077"/>
+            <a:ext cx="1425832" cy="479569"/>
+          </a:xfrm>
+          <a:prstGeom prst="rect">
+            <a:avLst/>
+          </a:prstGeom>
+          <a:solidFill>
+            <a:sysClr val="window" lastClr="FFFFFF"/>
+          </a:solidFill>
+          <a:ln w="12700" cap="flat" cmpd="sng" algn="ctr">
+            <a:solidFill>
+              <a:srgbClr val="A5A5A5"/>
+            </a:solidFill>
+            <a:prstDash val="solid"/>
+            <a:miter lim="800000"/>
+          </a:ln>
+          <a:effectLst/>
+        </p:spPr>
+        <p:txBody>
+          <a:bodyPr lIns="36000" tIns="36000" rIns="36000" bIns="36000" rtlCol="0" anchor="t"/>
+          <a:lstStyle/>
+          <a:p>
+            <a:pPr defTabSz="914400">
+              <a:defRPr/>
+            </a:pPr>
+            <a:r>
+              <a:rPr lang="de-DE" sz="800" kern="0">
+                <a:solidFill>
+                  <a:prstClr val="black"/>
+                </a:solidFill>
+                <a:latin typeface="Calibri" panose="020F0502020204030204"/>
+              </a:rPr>
+              <a:t>local-id=[mediatorUserName]</a:t>
+            </a:r>
+          </a:p>
+          <a:p>
+            <a:pPr defTabSz="914400"/>
+            <a:r>
+              <a:rPr lang="de-DE" sz="800" kern="0">
+                <a:solidFill>
+                  <a:prstClr val="black"/>
+                </a:solidFill>
+                <a:latin typeface="Calibri" panose="020F0502020204030204"/>
+              </a:rPr>
+              <a:t>mediatorUserName</a:t>
+            </a:r>
+          </a:p>
+          <a:p>
+            <a:pPr defTabSz="914400"/>
+            <a:r>
+              <a:rPr lang="de-DE" sz="800" kern="0">
+                <a:solidFill>
+                  <a:prstClr val="black"/>
+                </a:solidFill>
+                <a:latin typeface="Calibri" panose="020F0502020204030204"/>
+              </a:rPr>
+              <a:t>mediatorUserPassword</a:t>
+            </a:r>
+            <a:endParaRPr lang="de-DE" sz="800" kern="0" dirty="0">
+              <a:solidFill>
+                <a:prstClr val="black"/>
+              </a:solidFill>
+              <a:latin typeface="Calibri" panose="020F0502020204030204"/>
+            </a:endParaRPr>
+          </a:p>
+        </p:txBody>
+      </p:sp>
+      <p:cxnSp>
+        <p:nvCxnSpPr>
           <p:cNvPr id="235" name="Gerade Verbindung mit Pfeil 234">
             <a:extLst>
               <a:ext uri="{FF2B5EF4-FFF2-40B4-BE49-F238E27FC236}">
@@ -6112,42 +6472,63 @@
           <a:p>
             <a:pPr defTabSz="914400"/>
             <a:r>
-              <a:rPr lang="de-DE" sz="800" kern="0">
+              <a:rPr lang="de-DE" sz="800" kern="0" dirty="0">
                 <a:solidFill>
                   <a:prstClr val="black"/>
                 </a:solidFill>
                 <a:latin typeface="Calibri" panose="020F0502020204030204"/>
               </a:rPr>
-              <a:t>local-id=[deviceName]</a:t>
+              <a:t>element-name=[</a:t>
+            </a:r>
+            <a:r>
+              <a:rPr lang="de-DE" sz="800" kern="0" dirty="0" err="1">
+                <a:solidFill>
+                  <a:prstClr val="black"/>
+                </a:solidFill>
+                <a:latin typeface="Calibri" panose="020F0502020204030204"/>
+              </a:rPr>
+              <a:t>deviceName</a:t>
+            </a:r>
+            <a:r>
+              <a:rPr lang="de-DE" sz="800" kern="0" dirty="0">
+                <a:solidFill>
+                  <a:prstClr val="black"/>
+                </a:solidFill>
+                <a:latin typeface="Calibri" panose="020F0502020204030204"/>
+              </a:rPr>
+              <a:t>]</a:t>
             </a:r>
           </a:p>
           <a:p>
             <a:pPr defTabSz="914400"/>
             <a:r>
-              <a:rPr lang="de-DE" sz="800" kern="0">
+              <a:rPr lang="de-DE" sz="800" kern="0" dirty="0" err="1">
                 <a:solidFill>
                   <a:prstClr val="black"/>
                 </a:solidFill>
                 <a:latin typeface="Calibri" panose="020F0502020204030204"/>
               </a:rPr>
-              <a:t>category=device</a:t>
-            </a:r>
-          </a:p>
-          <a:p>
-            <a:pPr defTabSz="914400"/>
-            <a:r>
-              <a:rPr lang="de-DE" sz="800" kern="0">
+              <a:t>category</a:t>
+            </a:r>
+            <a:r>
+              <a:rPr lang="de-DE" sz="800" kern="0" dirty="0">
                 <a:solidFill>
                   <a:prstClr val="black"/>
                 </a:solidFill>
                 <a:latin typeface="Calibri" panose="020F0502020204030204"/>
               </a:rPr>
-              <a:t>_template=deviceTemplateName</a:t>
-            </a:r>
-          </a:p>
-          <a:p>
-            <a:pPr defTabSz="914400"/>
-            <a:endParaRPr lang="de-DE" sz="800" kern="0">
+              <a:t>=</a:t>
+            </a:r>
+            <a:r>
+              <a:rPr lang="de-DE" sz="800" kern="0" dirty="0" err="1">
+                <a:solidFill>
+                  <a:prstClr val="black"/>
+                </a:solidFill>
+                <a:latin typeface="Calibri" panose="020F0502020204030204"/>
+              </a:rPr>
+              <a:t>device</a:t>
+            </a:r>
+            <a:endParaRPr lang="de-DE" sz="800" kern="0" dirty="0">
               <a:solidFill>
                 <a:prstClr val="black"/>
               </a:solidFill>
@@ -6156,7 +6537,61 @@
           </a:p>
           <a:p>
             <a:pPr defTabSz="914400"/>
-            <a:endParaRPr lang="de-DE" sz="800" kern="0">
+            <a:r>
+              <a:rPr lang="de-DE" sz="800" kern="0" dirty="0">
+                <a:solidFill>
+                  <a:prstClr val="black"/>
+                </a:solidFill>
+                <a:latin typeface="Calibri" panose="020F0502020204030204"/>
+              </a:rPr>
+              <a:t>_</a:t>
+            </a:r>
+            <a:r>
+              <a:rPr lang="de-DE" sz="800" kern="0" dirty="0" err="1">
+                <a:solidFill>
+                  <a:prstClr val="black"/>
+                </a:solidFill>
+                <a:latin typeface="Calibri" panose="020F0502020204030204"/>
+              </a:rPr>
+              <a:t>template</a:t>
+            </a:r>
+            <a:r>
+              <a:rPr lang="de-DE" sz="800" kern="0" dirty="0">
+                <a:solidFill>
+                  <a:prstClr val="black"/>
+                </a:solidFill>
+                <a:latin typeface="Calibri" panose="020F0502020204030204"/>
+              </a:rPr>
+              <a:t>=</a:t>
+            </a:r>
+            <a:r>
+              <a:rPr lang="de-DE" sz="800" kern="0" dirty="0" err="1">
+                <a:solidFill>
+                  <a:prstClr val="black"/>
+                </a:solidFill>
+                <a:latin typeface="Calibri" panose="020F0502020204030204"/>
+              </a:rPr>
+              <a:t>deviceTemplateName</a:t>
+            </a:r>
+            <a:endParaRPr lang="de-DE" sz="800" kern="0" dirty="0">
+              <a:solidFill>
+                <a:prstClr val="black"/>
+              </a:solidFill>
+              <a:latin typeface="Calibri" panose="020F0502020204030204"/>
+            </a:endParaRPr>
+          </a:p>
+          <a:p>
+            <a:pPr defTabSz="914400"/>
+            <a:endParaRPr lang="de-DE" sz="800" kern="0" dirty="0">
+              <a:solidFill>
+                <a:prstClr val="black"/>
+              </a:solidFill>
+              <a:latin typeface="Calibri" panose="020F0502020204030204"/>
+            </a:endParaRPr>
+          </a:p>
+          <a:p>
+            <a:pPr defTabSz="914400"/>
+            <a:endParaRPr lang="de-DE" sz="800" kern="0" dirty="0">
               <a:solidFill>
                 <a:prstClr val="black"/>
               </a:solidFill>
@@ -7440,8 +7875,8 @@
         </p:nvSpPr>
         <p:spPr>
           <a:xfrm>
-            <a:off x="12358907" y="5854380"/>
-            <a:ext cx="1703846" cy="310594"/>
+            <a:off x="12387482" y="5844855"/>
+            <a:ext cx="2528668" cy="310594"/>
           </a:xfrm>
           <a:prstGeom prst="rect">
             <a:avLst/>
@@ -7464,13 +7899,58 @@
           <a:p>
             <a:pPr defTabSz="914400"/>
             <a:r>
-              <a:rPr lang="de-DE" sz="800" kern="0">
+              <a:rPr lang="de-DE" sz="800" kern="0" dirty="0" err="1">
                 <a:solidFill>
                   <a:prstClr val="black"/>
                 </a:solidFill>
                 <a:latin typeface="Calibri" panose="020F0502020204030204"/>
               </a:rPr>
-              <a:t>local-id=[deviceName]</a:t>
+              <a:t>forwarding</a:t>
+            </a:r>
+            <a:r>
+              <a:rPr lang="de-DE" sz="800" kern="0" dirty="0">
+                <a:solidFill>
+                  <a:prstClr val="black"/>
+                </a:solidFill>
+                <a:latin typeface="Calibri" panose="020F0502020204030204"/>
+              </a:rPr>
+              <a:t>-</a:t>
+            </a:r>
+            <a:r>
+              <a:rPr lang="de-DE" sz="800" kern="0" dirty="0" err="1">
+                <a:solidFill>
+                  <a:prstClr val="black"/>
+                </a:solidFill>
+                <a:latin typeface="Calibri" panose="020F0502020204030204"/>
+              </a:rPr>
+              <a:t>construct</a:t>
+            </a:r>
+            <a:r>
+              <a:rPr lang="de-DE" sz="800" kern="0" dirty="0">
+                <a:solidFill>
+                  <a:prstClr val="black"/>
+                </a:solidFill>
+                <a:latin typeface="Calibri" panose="020F0502020204030204"/>
+              </a:rPr>
+              <a:t>-name =[</a:t>
+            </a:r>
+            <a:r>
+              <a:rPr lang="de-DE" sz="800" kern="0" dirty="0" err="1">
+                <a:solidFill>
+                  <a:prstClr val="black"/>
+                </a:solidFill>
+                <a:latin typeface="Calibri" panose="020F0502020204030204"/>
+              </a:rPr>
+              <a:t>deviceName</a:t>
+            </a:r>
+            <a:r>
+              <a:rPr lang="de-DE" sz="800" kern="0" dirty="0">
+                <a:solidFill>
+                  <a:prstClr val="black"/>
+                </a:solidFill>
+                <a:latin typeface="Calibri" panose="020F0502020204030204"/>
+              </a:rPr>
+              <a:t>]</a:t>
             </a:r>
           </a:p>
         </p:txBody>
@@ -7494,7 +7974,7 @@
         <p:spPr>
           <a:xfrm>
             <a:off x="11382119" y="5794854"/>
-            <a:ext cx="976788" cy="214823"/>
+            <a:ext cx="1005363" cy="205298"/>
           </a:xfrm>
           <a:prstGeom prst="straightConnector1">
             <a:avLst/>
@@ -7526,7 +8006,7 @@
         <p:spPr>
           <a:xfrm>
             <a:off x="12354266" y="4728077"/>
-            <a:ext cx="1713783" cy="336074"/>
+            <a:ext cx="2561884" cy="336074"/>
           </a:xfrm>
           <a:prstGeom prst="rect">
             <a:avLst/>
@@ -7549,13 +8029,22 @@
           <a:p>
             <a:pPr defTabSz="914400"/>
             <a:r>
-              <a:rPr lang="de-DE" sz="800" kern="0">
+              <a:rPr lang="de-DE" sz="800" kern="0" dirty="0" err="1">
                 <a:solidFill>
                   <a:prstClr val="black"/>
                 </a:solidFill>
                 <a:latin typeface="Calibri" panose="020F0502020204030204"/>
               </a:rPr>
-              <a:t>local-id=management-plane-transport</a:t>
+              <a:t>forwarding</a:t>
+            </a:r>
+            <a:r>
+              <a:rPr lang="de-DE" sz="800" kern="0" dirty="0">
+                <a:solidFill>
+                  <a:prstClr val="black"/>
+                </a:solidFill>
+                <a:latin typeface="Calibri" panose="020F0502020204030204"/>
+              </a:rPr>
+              <a:t>-domain-name =management-plane-transport</a:t>
             </a:r>
           </a:p>
         </p:txBody>
@@ -7670,13 +8159,31 @@
               <a:defRPr/>
             </a:pPr>
             <a:r>
-              <a:rPr lang="de-DE" sz="800" kern="0">
+              <a:rPr lang="de-DE" sz="800" kern="0" dirty="0">
                 <a:solidFill>
                   <a:prstClr val="black"/>
                 </a:solidFill>
                 <a:latin typeface="Calibri" panose="020F0502020204030204"/>
               </a:rPr>
-              <a:t>local-id=[controllerName]</a:t>
+              <a:t>element-name=[</a:t>
+            </a:r>
+            <a:r>
+              <a:rPr lang="de-DE" sz="800" kern="0" dirty="0" err="1">
+                <a:solidFill>
+                  <a:prstClr val="black"/>
+                </a:solidFill>
+                <a:latin typeface="Calibri" panose="020F0502020204030204"/>
+              </a:rPr>
+              <a:t>controllerName</a:t>
+            </a:r>
+            <a:r>
+              <a:rPr lang="de-DE" sz="800" kern="0" dirty="0">
+                <a:solidFill>
+                  <a:prstClr val="black"/>
+                </a:solidFill>
+                <a:latin typeface="Calibri" panose="020F0502020204030204"/>
+              </a:rPr>
+              <a:t>]</a:t>
             </a:r>
           </a:p>
           <a:p>
@@ -7684,28 +8191,85 @@
               <a:defRPr/>
             </a:pPr>
             <a:r>
-              <a:rPr lang="de-DE" sz="800" kern="0">
+              <a:rPr lang="de-DE" sz="800" kern="0" dirty="0" err="1">
                 <a:solidFill>
                   <a:prstClr val="black"/>
                 </a:solidFill>
                 <a:latin typeface="Calibri" panose="020F0502020204030204"/>
               </a:rPr>
-              <a:t>category=controller</a:t>
-            </a:r>
+              <a:t>category</a:t>
+            </a:r>
+            <a:r>
+              <a:rPr lang="de-DE" sz="800" kern="0" dirty="0">
+                <a:solidFill>
+                  <a:prstClr val="black"/>
+                </a:solidFill>
+                <a:latin typeface="Calibri" panose="020F0502020204030204"/>
+              </a:rPr>
+              <a:t>=</a:t>
+            </a:r>
+            <a:r>
+              <a:rPr lang="de-DE" sz="800" kern="0" dirty="0" err="1">
+                <a:solidFill>
+                  <a:prstClr val="black"/>
+                </a:solidFill>
+                <a:latin typeface="Calibri" panose="020F0502020204030204"/>
+              </a:rPr>
+              <a:t>controller</a:t>
+            </a:r>
+            <a:endParaRPr lang="de-DE" sz="800" kern="0" dirty="0">
+              <a:solidFill>
+                <a:prstClr val="black"/>
+              </a:solidFill>
+              <a:latin typeface="Calibri" panose="020F0502020204030204"/>
+            </a:endParaRPr>
           </a:p>
           <a:p>
             <a:pPr defTabSz="914400">
               <a:defRPr/>
             </a:pPr>
             <a:r>
-              <a:rPr lang="de-DE" sz="800" kern="0">
+              <a:rPr lang="de-DE" sz="800" kern="0" dirty="0">
                 <a:solidFill>
                   <a:prstClr val="black"/>
                 </a:solidFill>
                 <a:latin typeface="Calibri" panose="020F0502020204030204"/>
               </a:rPr>
-              <a:t>_template=controllerTemplateName</a:t>
-            </a:r>
+              <a:t>_</a:t>
+            </a:r>
+            <a:r>
+              <a:rPr lang="de-DE" sz="800" kern="0" dirty="0" err="1">
+                <a:solidFill>
+                  <a:prstClr val="black"/>
+                </a:solidFill>
+                <a:latin typeface="Calibri" panose="020F0502020204030204"/>
+              </a:rPr>
+              <a:t>template</a:t>
+            </a:r>
+            <a:r>
+              <a:rPr lang="de-DE" sz="800" kern="0" dirty="0">
+                <a:solidFill>
+                  <a:prstClr val="black"/>
+                </a:solidFill>
+                <a:latin typeface="Calibri" panose="020F0502020204030204"/>
+              </a:rPr>
+              <a:t>=</a:t>
+            </a:r>
+            <a:r>
+              <a:rPr lang="de-DE" sz="800" kern="0" dirty="0" err="1">
+                <a:solidFill>
+                  <a:prstClr val="black"/>
+                </a:solidFill>
+                <a:latin typeface="Calibri" panose="020F0502020204030204"/>
+              </a:rPr>
+              <a:t>controllerTemplateName</a:t>
+            </a:r>
+            <a:endParaRPr lang="de-DE" sz="800" kern="0" dirty="0">
+              <a:solidFill>
+                <a:prstClr val="black"/>
+              </a:solidFill>
+              <a:latin typeface="Calibri" panose="020F0502020204030204"/>
+            </a:endParaRPr>
           </a:p>
         </p:txBody>
       </p:sp>
@@ -7747,13 +8311,40 @@
           <a:p>
             <a:pPr defTabSz="914400"/>
             <a:r>
-              <a:rPr lang="de-DE" sz="800" kern="0">
+              <a:rPr lang="de-DE" sz="800" kern="0" dirty="0" err="1">
                 <a:solidFill>
                   <a:prstClr val="black"/>
                 </a:solidFill>
                 <a:latin typeface="Calibri" panose="020F0502020204030204"/>
               </a:rPr>
-              <a:t>local-id =running,operational, …</a:t>
+              <a:t>storage</a:t>
+            </a:r>
+            <a:r>
+              <a:rPr lang="de-DE" sz="800" kern="0" dirty="0">
+                <a:solidFill>
+                  <a:prstClr val="black"/>
+                </a:solidFill>
+                <a:latin typeface="Calibri" panose="020F0502020204030204"/>
+              </a:rPr>
+              <a:t> =</a:t>
+            </a:r>
+            <a:r>
+              <a:rPr lang="de-DE" sz="800" kern="0" dirty="0" err="1">
+                <a:solidFill>
+                  <a:prstClr val="black"/>
+                </a:solidFill>
+                <a:latin typeface="Calibri" panose="020F0502020204030204"/>
+              </a:rPr>
+              <a:t>running,operational</a:t>
+            </a:r>
+            <a:r>
+              <a:rPr lang="de-DE" sz="800" kern="0" dirty="0">
+                <a:solidFill>
+                  <a:prstClr val="black"/>
+                </a:solidFill>
+                <a:latin typeface="Calibri" panose="020F0502020204030204"/>
+              </a:rPr>
+              <a:t>, …</a:t>
             </a:r>
           </a:p>
         </p:txBody>
@@ -10623,8 +11214,8 @@
         </p:nvSpPr>
         <p:spPr>
           <a:xfrm>
-            <a:off x="6991939" y="358770"/>
-            <a:ext cx="722507" cy="356322"/>
+            <a:off x="6851185" y="358770"/>
+            <a:ext cx="863261" cy="356322"/>
           </a:xfrm>
           <a:prstGeom prst="rect">
             <a:avLst/>
@@ -10647,19 +11238,28 @@
           <a:p>
             <a:pPr defTabSz="914400"/>
             <a:r>
-              <a:rPr lang="de-DE" sz="800" kern="0">
+              <a:rPr lang="de-DE" sz="800" kern="0" dirty="0" err="1">
                 <a:solidFill>
                   <a:prstClr val="black"/>
                 </a:solidFill>
                 <a:latin typeface="Calibri" panose="020F0502020204030204"/>
               </a:rPr>
-              <a:t>functionName</a:t>
+              <a:t>function</a:t>
+            </a:r>
+            <a:r>
+              <a:rPr lang="de-DE" sz="800" kern="0" dirty="0">
+                <a:solidFill>
+                  <a:prstClr val="black"/>
+                </a:solidFill>
+                <a:latin typeface="Calibri" panose="020F0502020204030204"/>
+              </a:rPr>
+              <a:t>-name</a:t>
             </a:r>
           </a:p>
           <a:p>
             <a:pPr defTabSz="914400"/>
             <a:r>
-              <a:rPr lang="de-DE" sz="800" kern="0">
+              <a:rPr lang="de-DE" sz="800" kern="0" dirty="0" err="1">
                 <a:solidFill>
                   <a:prstClr val="black"/>
                 </a:solidFill>
@@ -10667,6 +11267,12 @@
               </a:rPr>
               <a:t>parameter</a:t>
             </a:r>
+            <a:endParaRPr lang="de-DE" sz="800" kern="0" dirty="0">
+              <a:solidFill>
+                <a:prstClr val="black"/>
+              </a:solidFill>
+              <a:latin typeface="Calibri" panose="020F0502020204030204"/>
+            </a:endParaRPr>
           </a:p>
         </p:txBody>
       </p:sp>

</xml_diff>

<commit_message>
Fix source of data in Operational if element-name
</commit_message>
<xml_diff>
--- a/spec/InformationStructure/diagrams/InformationStructure.pptx
+++ b/spec/InformationStructure/diagrams/InformationStructure.pptx
@@ -209,7 +209,7 @@
           <a:p>
             <a:fld id="{37CCF725-7468-4D3D-9E24-A16745BBBA77}" type="datetimeFigureOut">
               <a:rPr lang="de-DE" smtClean="0"/>
-              <a:t>16.05.2025</a:t>
+              <a:t>27.06.2025</a:t>
             </a:fld>
             <a:endParaRPr lang="de-DE"/>
           </a:p>
@@ -607,7 +607,7 @@
           <a:p>
             <a:fld id="{9A2764DB-E7DF-4EA7-A1AF-05A77C280FCA}" type="datetimeFigureOut">
               <a:rPr lang="de-DE" smtClean="0"/>
-              <a:t>16.05.2025</a:t>
+              <a:t>27.06.2025</a:t>
             </a:fld>
             <a:endParaRPr lang="de-DE"/>
           </a:p>
@@ -777,7 +777,7 @@
           <a:p>
             <a:fld id="{9A2764DB-E7DF-4EA7-A1AF-05A77C280FCA}" type="datetimeFigureOut">
               <a:rPr lang="de-DE" smtClean="0"/>
-              <a:t>16.05.2025</a:t>
+              <a:t>27.06.2025</a:t>
             </a:fld>
             <a:endParaRPr lang="de-DE"/>
           </a:p>
@@ -957,7 +957,7 @@
           <a:p>
             <a:fld id="{9A2764DB-E7DF-4EA7-A1AF-05A77C280FCA}" type="datetimeFigureOut">
               <a:rPr lang="de-DE" smtClean="0"/>
-              <a:t>16.05.2025</a:t>
+              <a:t>27.06.2025</a:t>
             </a:fld>
             <a:endParaRPr lang="de-DE"/>
           </a:p>
@@ -1127,7 +1127,7 @@
           <a:p>
             <a:fld id="{9A2764DB-E7DF-4EA7-A1AF-05A77C280FCA}" type="datetimeFigureOut">
               <a:rPr lang="de-DE" smtClean="0"/>
-              <a:t>16.05.2025</a:t>
+              <a:t>27.06.2025</a:t>
             </a:fld>
             <a:endParaRPr lang="de-DE"/>
           </a:p>
@@ -1373,7 +1373,7 @@
           <a:p>
             <a:fld id="{9A2764DB-E7DF-4EA7-A1AF-05A77C280FCA}" type="datetimeFigureOut">
               <a:rPr lang="de-DE" smtClean="0"/>
-              <a:t>16.05.2025</a:t>
+              <a:t>27.06.2025</a:t>
             </a:fld>
             <a:endParaRPr lang="de-DE"/>
           </a:p>
@@ -1605,7 +1605,7 @@
           <a:p>
             <a:fld id="{9A2764DB-E7DF-4EA7-A1AF-05A77C280FCA}" type="datetimeFigureOut">
               <a:rPr lang="de-DE" smtClean="0"/>
-              <a:t>16.05.2025</a:t>
+              <a:t>27.06.2025</a:t>
             </a:fld>
             <a:endParaRPr lang="de-DE"/>
           </a:p>
@@ -1972,7 +1972,7 @@
           <a:p>
             <a:fld id="{9A2764DB-E7DF-4EA7-A1AF-05A77C280FCA}" type="datetimeFigureOut">
               <a:rPr lang="de-DE" smtClean="0"/>
-              <a:t>16.05.2025</a:t>
+              <a:t>27.06.2025</a:t>
             </a:fld>
             <a:endParaRPr lang="de-DE"/>
           </a:p>
@@ -2090,7 +2090,7 @@
           <a:p>
             <a:fld id="{9A2764DB-E7DF-4EA7-A1AF-05A77C280FCA}" type="datetimeFigureOut">
               <a:rPr lang="de-DE" smtClean="0"/>
-              <a:t>16.05.2025</a:t>
+              <a:t>27.06.2025</a:t>
             </a:fld>
             <a:endParaRPr lang="de-DE"/>
           </a:p>
@@ -2185,7 +2185,7 @@
           <a:p>
             <a:fld id="{9A2764DB-E7DF-4EA7-A1AF-05A77C280FCA}" type="datetimeFigureOut">
               <a:rPr lang="de-DE" smtClean="0"/>
-              <a:t>16.05.2025</a:t>
+              <a:t>27.06.2025</a:t>
             </a:fld>
             <a:endParaRPr lang="de-DE"/>
           </a:p>
@@ -2462,7 +2462,7 @@
           <a:p>
             <a:fld id="{9A2764DB-E7DF-4EA7-A1AF-05A77C280FCA}" type="datetimeFigureOut">
               <a:rPr lang="de-DE" smtClean="0"/>
-              <a:t>16.05.2025</a:t>
+              <a:t>27.06.2025</a:t>
             </a:fld>
             <a:endParaRPr lang="de-DE"/>
           </a:p>
@@ -2719,7 +2719,7 @@
           <a:p>
             <a:fld id="{9A2764DB-E7DF-4EA7-A1AF-05A77C280FCA}" type="datetimeFigureOut">
               <a:rPr lang="de-DE" smtClean="0"/>
-              <a:t>16.05.2025</a:t>
+              <a:t>27.06.2025</a:t>
             </a:fld>
             <a:endParaRPr lang="de-DE"/>
           </a:p>
@@ -2932,7 +2932,7 @@
           <a:p>
             <a:fld id="{9A2764DB-E7DF-4EA7-A1AF-05A77C280FCA}" type="datetimeFigureOut">
               <a:rPr lang="de-DE" smtClean="0"/>
-              <a:t>16.05.2025</a:t>
+              <a:t>27.06.2025</a:t>
             </a:fld>
             <a:endParaRPr lang="de-DE"/>
           </a:p>
@@ -4825,8 +4825,8 @@
         </p:nvSpPr>
         <p:spPr>
           <a:xfrm>
-            <a:off x="13537391" y="12788610"/>
-            <a:ext cx="1682087" cy="487489"/>
+            <a:off x="13537391" y="12452350"/>
+            <a:ext cx="1682087" cy="823749"/>
           </a:xfrm>
           <a:prstGeom prst="rect">
             <a:avLst/>
@@ -4849,48 +4849,144 @@
           <a:p>
             <a:pPr defTabSz="914400"/>
             <a:r>
-              <a:rPr lang="de-DE" sz="800" kern="0">
+              <a:rPr lang="de-DE" sz="800" kern="0" dirty="0" err="1">
                 <a:solidFill>
                   <a:prstClr val="black"/>
                 </a:solidFill>
                 <a:latin typeface="Calibri" panose="020F0502020204030204"/>
               </a:rPr>
-              <a:t>local-id=snmpClient</a:t>
-            </a:r>
-          </a:p>
-          <a:p>
-            <a:pPr defTabSz="914400"/>
-            <a:r>
-              <a:rPr lang="de-DE" sz="800" kern="0">
+              <a:t>local-id</a:t>
+            </a:r>
+            <a:r>
+              <a:rPr lang="de-DE" sz="800" kern="0" dirty="0">
                 <a:solidFill>
                   <a:prstClr val="black"/>
                 </a:solidFill>
                 <a:latin typeface="Calibri" panose="020F0502020204030204"/>
               </a:rPr>
-              <a:t>mediatorUserName</a:t>
-            </a:r>
-          </a:p>
-          <a:p>
-            <a:pPr defTabSz="914400"/>
-            <a:r>
-              <a:rPr lang="de-DE" sz="800" kern="0">
+              <a:t>=</a:t>
+            </a:r>
+            <a:r>
+              <a:rPr lang="de-DE" sz="800" kern="0" dirty="0" err="1">
                 <a:solidFill>
                   <a:prstClr val="black"/>
                 </a:solidFill>
                 <a:latin typeface="Calibri" panose="020F0502020204030204"/>
               </a:rPr>
-              <a:t>mediatorUserPassword</a:t>
-            </a:r>
-          </a:p>
-          <a:p>
-            <a:pPr defTabSz="914400"/>
-            <a:endParaRPr lang="de-DE" sz="800" kern="0">
+              <a:t>snmpClient</a:t>
+            </a:r>
+            <a:endParaRPr lang="de-DE" sz="800" kern="0" dirty="0">
               <a:solidFill>
                 <a:prstClr val="black"/>
               </a:solidFill>
               <a:latin typeface="Calibri" panose="020F0502020204030204"/>
             </a:endParaRPr>
           </a:p>
+          <a:p>
+            <a:pPr defTabSz="914400"/>
+            <a:r>
+              <a:rPr lang="de-DE" sz="800" strike="sngStrike" kern="0" dirty="0" err="1">
+                <a:solidFill>
+                  <a:prstClr val="black"/>
+                </a:solidFill>
+                <a:highlight>
+                  <a:srgbClr val="FFFF00"/>
+                </a:highlight>
+                <a:latin typeface="Calibri" panose="020F0502020204030204"/>
+              </a:rPr>
+              <a:t>mediatorUserName</a:t>
+            </a:r>
+            <a:endParaRPr lang="de-DE" sz="800" strike="sngStrike" kern="0" dirty="0">
+              <a:solidFill>
+                <a:prstClr val="black"/>
+              </a:solidFill>
+              <a:highlight>
+                <a:srgbClr val="FFFF00"/>
+              </a:highlight>
+              <a:latin typeface="Calibri" panose="020F0502020204030204"/>
+            </a:endParaRPr>
+          </a:p>
+          <a:p>
+            <a:pPr defTabSz="914400"/>
+            <a:r>
+              <a:rPr lang="de-DE" sz="800" strike="sngStrike" kern="0" dirty="0" err="1">
+                <a:solidFill>
+                  <a:prstClr val="black"/>
+                </a:solidFill>
+                <a:highlight>
+                  <a:srgbClr val="FFFF00"/>
+                </a:highlight>
+                <a:latin typeface="Calibri" panose="020F0502020204030204"/>
+              </a:rPr>
+              <a:t>mediatorUserPassword</a:t>
+            </a:r>
+            <a:endParaRPr lang="de-DE" sz="800" strike="sngStrike" kern="0" dirty="0">
+              <a:solidFill>
+                <a:prstClr val="black"/>
+              </a:solidFill>
+              <a:highlight>
+                <a:srgbClr val="FFFF00"/>
+              </a:highlight>
+              <a:latin typeface="Calibri" panose="020F0502020204030204"/>
+            </a:endParaRPr>
+          </a:p>
+          <a:p>
+            <a:pPr defTabSz="914400"/>
+            <a:r>
+              <a:rPr lang="de-DE" sz="800" kern="0" dirty="0" err="1">
+                <a:solidFill>
+                  <a:prstClr val="black"/>
+                </a:solidFill>
+                <a:highlight>
+                  <a:srgbClr val="FFFF00"/>
+                </a:highlight>
+                <a:latin typeface="Calibri" panose="020F0502020204030204"/>
+              </a:rPr>
+              <a:t>snmpUserName</a:t>
+            </a:r>
+            <a:endParaRPr lang="de-DE" sz="800" kern="0" dirty="0">
+              <a:solidFill>
+                <a:prstClr val="black"/>
+              </a:solidFill>
+              <a:highlight>
+                <a:srgbClr val="FFFF00"/>
+              </a:highlight>
+              <a:latin typeface="Calibri" panose="020F0502020204030204"/>
+            </a:endParaRPr>
+          </a:p>
+          <a:p>
+            <a:pPr defTabSz="914400"/>
+            <a:r>
+              <a:rPr lang="de-DE" sz="800" kern="0" dirty="0" err="1">
+                <a:solidFill>
+                  <a:prstClr val="black"/>
+                </a:solidFill>
+                <a:highlight>
+                  <a:srgbClr val="FFFF00"/>
+                </a:highlight>
+                <a:latin typeface="Calibri" panose="020F0502020204030204"/>
+              </a:rPr>
+              <a:t>snmpUserPassword</a:t>
+            </a:r>
+            <a:endParaRPr lang="de-DE" sz="800" kern="0" dirty="0">
+              <a:solidFill>
+                <a:prstClr val="black"/>
+              </a:solidFill>
+              <a:highlight>
+                <a:srgbClr val="FFFF00"/>
+              </a:highlight>
+              <a:latin typeface="Calibri" panose="020F0502020204030204"/>
+            </a:endParaRPr>
+          </a:p>
+          <a:p>
+            <a:pPr defTabSz="914400"/>
+            <a:endParaRPr lang="de-DE" sz="800" kern="0" dirty="0">
+              <a:solidFill>
+                <a:prstClr val="black"/>
+              </a:solidFill>
+              <a:latin typeface="Calibri" panose="020F0502020204030204"/>
+            </a:endParaRPr>
+          </a:p>
         </p:txBody>
       </p:sp>
       <p:cxnSp>
@@ -4910,9 +5006,9 @@
           <p:nvPr/>
         </p:nvCxnSpPr>
         <p:spPr>
-          <a:xfrm>
-            <a:off x="13067183" y="12995178"/>
-            <a:ext cx="470208" cy="37177"/>
+          <a:xfrm flipV="1">
+            <a:off x="13067183" y="12864225"/>
+            <a:ext cx="470208" cy="130953"/>
           </a:xfrm>
           <a:prstGeom prst="straightConnector1">
             <a:avLst/>
@@ -5396,38 +5492,86 @@
           <a:p>
             <a:pPr defTabSz="914400"/>
             <a:r>
-              <a:rPr lang="de-DE" sz="800" kern="0">
+              <a:rPr lang="de-DE" sz="800" kern="0" dirty="0" err="1">
                 <a:solidFill>
                   <a:prstClr val="black"/>
                 </a:solidFill>
                 <a:latin typeface="Calibri" panose="020F0502020204030204"/>
               </a:rPr>
-              <a:t>local-id=mimHttpServer</a:t>
-            </a:r>
+              <a:t>local-id</a:t>
+            </a:r>
+            <a:r>
+              <a:rPr lang="de-DE" sz="800" kern="0" dirty="0">
+                <a:solidFill>
+                  <a:prstClr val="black"/>
+                </a:solidFill>
+                <a:latin typeface="Calibri" panose="020F0502020204030204"/>
+              </a:rPr>
+              <a:t>=</a:t>
+            </a:r>
+            <a:r>
+              <a:rPr lang="de-DE" sz="800" kern="0" dirty="0" err="1">
+                <a:solidFill>
+                  <a:prstClr val="black"/>
+                </a:solidFill>
+                <a:latin typeface="Calibri" panose="020F0502020204030204"/>
+              </a:rPr>
+              <a:t>mimHttpServer</a:t>
+            </a:r>
+            <a:endParaRPr lang="de-DE" sz="800" kern="0" dirty="0">
+              <a:solidFill>
+                <a:prstClr val="black"/>
+              </a:solidFill>
+              <a:latin typeface="Calibri" panose="020F0502020204030204"/>
+            </a:endParaRPr>
           </a:p>
           <a:p>
             <a:pPr defTabSz="914400"/>
             <a:r>
-              <a:rPr lang="de-DE" sz="800" kern="0">
+              <a:rPr lang="de-DE" sz="800" strike="sngStrike" kern="0" dirty="0" err="1">
                 <a:solidFill>
                   <a:prstClr val="black"/>
                 </a:solidFill>
+                <a:highlight>
+                  <a:srgbClr val="FFFF00"/>
+                </a:highlight>
                 <a:latin typeface="Calibri" panose="020F0502020204030204"/>
               </a:rPr>
               <a:t>mediatorUserName</a:t>
             </a:r>
+            <a:endParaRPr lang="de-DE" sz="800" strike="sngStrike" kern="0" dirty="0">
+              <a:solidFill>
+                <a:prstClr val="black"/>
+              </a:solidFill>
+              <a:highlight>
+                <a:srgbClr val="FFFF00"/>
+              </a:highlight>
+              <a:latin typeface="Calibri" panose="020F0502020204030204"/>
+            </a:endParaRPr>
           </a:p>
           <a:p>
             <a:pPr defTabSz="914400"/>
             <a:r>
-              <a:rPr lang="de-DE" sz="800" kern="0">
+              <a:rPr lang="de-DE" sz="800" strike="sngStrike" kern="0" dirty="0" err="1">
                 <a:solidFill>
                   <a:prstClr val="black"/>
                 </a:solidFill>
+                <a:highlight>
+                  <a:srgbClr val="FFFF00"/>
+                </a:highlight>
                 <a:latin typeface="Calibri" panose="020F0502020204030204"/>
               </a:rPr>
               <a:t>mediatorUserPassword</a:t>
             </a:r>
+            <a:endParaRPr lang="de-DE" sz="800" strike="sngStrike" kern="0" dirty="0">
+              <a:solidFill>
+                <a:prstClr val="black"/>
+              </a:solidFill>
+              <a:highlight>
+                <a:srgbClr val="FFFF00"/>
+              </a:highlight>
+              <a:latin typeface="Calibri" panose="020F0502020204030204"/>
+            </a:endParaRPr>
           </a:p>
         </p:txBody>
       </p:sp>
@@ -5517,8 +5661,8 @@
         </p:nvSpPr>
         <p:spPr>
           <a:xfrm>
-            <a:off x="8326115" y="7380577"/>
-            <a:ext cx="1815783" cy="512200"/>
+            <a:off x="8326115" y="7380576"/>
+            <a:ext cx="1815783" cy="725175"/>
           </a:xfrm>
           <a:prstGeom prst="rect">
             <a:avLst/>
@@ -5541,48 +5685,180 @@
           <a:p>
             <a:pPr defTabSz="914400"/>
             <a:r>
-              <a:rPr lang="de-DE" sz="800" kern="0">
+              <a:rPr lang="de-DE" sz="800" kern="0" dirty="0" err="1">
                 <a:solidFill>
                   <a:prstClr val="black"/>
                 </a:solidFill>
                 <a:latin typeface="Calibri" panose="020F0502020204030204"/>
               </a:rPr>
-              <a:t>local-id=[mediatorVmName]</a:t>
+              <a:t>local-id</a:t>
+            </a:r>
+            <a:r>
+              <a:rPr lang="de-DE" sz="800" kern="0" dirty="0">
+                <a:solidFill>
+                  <a:prstClr val="black"/>
+                </a:solidFill>
+                <a:latin typeface="Calibri" panose="020F0502020204030204"/>
+              </a:rPr>
+              <a:t>=[</a:t>
+            </a:r>
+            <a:r>
+              <a:rPr lang="de-DE" sz="800" kern="0" dirty="0" err="1">
+                <a:solidFill>
+                  <a:prstClr val="black"/>
+                </a:solidFill>
+                <a:latin typeface="Calibri" panose="020F0502020204030204"/>
+              </a:rPr>
+              <a:t>mediatorVmName</a:t>
+            </a:r>
+            <a:r>
+              <a:rPr lang="de-DE" sz="800" kern="0" dirty="0">
+                <a:solidFill>
+                  <a:prstClr val="black"/>
+                </a:solidFill>
+                <a:latin typeface="Calibri" panose="020F0502020204030204"/>
+              </a:rPr>
+              <a:t>]</a:t>
             </a:r>
           </a:p>
           <a:p>
             <a:pPr defTabSz="914400"/>
             <a:r>
-              <a:rPr lang="de-DE" sz="800" kern="0">
+              <a:rPr lang="de-DE" sz="800" kern="0" dirty="0" err="1">
                 <a:solidFill>
                   <a:prstClr val="black"/>
                 </a:solidFill>
                 <a:latin typeface="Calibri" panose="020F0502020204030204"/>
               </a:rPr>
-              <a:t>category=mediatorVm</a:t>
-            </a:r>
-          </a:p>
-          <a:p>
-            <a:pPr defTabSz="914400"/>
-            <a:r>
-              <a:rPr lang="de-DE" sz="800" kern="0">
+              <a:t>category</a:t>
+            </a:r>
+            <a:r>
+              <a:rPr lang="de-DE" sz="800" kern="0" dirty="0">
                 <a:solidFill>
                   <a:prstClr val="black"/>
                 </a:solidFill>
                 <a:latin typeface="Calibri" panose="020F0502020204030204"/>
               </a:rPr>
-              <a:t>_template= mediatorVmTemplateName</a:t>
-            </a:r>
-          </a:p>
-          <a:p>
-            <a:pPr defTabSz="914400"/>
-            <a:endParaRPr lang="de-DE" sz="800" kern="0">
+              <a:t>=</a:t>
+            </a:r>
+            <a:r>
+              <a:rPr lang="de-DE" sz="800" kern="0" dirty="0" err="1">
+                <a:solidFill>
+                  <a:prstClr val="black"/>
+                </a:solidFill>
+                <a:latin typeface="Calibri" panose="020F0502020204030204"/>
+              </a:rPr>
+              <a:t>mediatorVm</a:t>
+            </a:r>
+            <a:endParaRPr lang="de-DE" sz="800" kern="0" dirty="0">
               <a:solidFill>
                 <a:prstClr val="black"/>
               </a:solidFill>
               <a:latin typeface="Calibri" panose="020F0502020204030204"/>
             </a:endParaRPr>
           </a:p>
+          <a:p>
+            <a:pPr defTabSz="914400"/>
+            <a:r>
+              <a:rPr lang="de-DE" sz="800" kern="0" dirty="0">
+                <a:solidFill>
+                  <a:prstClr val="black"/>
+                </a:solidFill>
+                <a:latin typeface="Calibri" panose="020F0502020204030204"/>
+              </a:rPr>
+              <a:t>_</a:t>
+            </a:r>
+            <a:r>
+              <a:rPr lang="de-DE" sz="800" kern="0" dirty="0" err="1">
+                <a:solidFill>
+                  <a:prstClr val="black"/>
+                </a:solidFill>
+                <a:latin typeface="Calibri" panose="020F0502020204030204"/>
+              </a:rPr>
+              <a:t>template</a:t>
+            </a:r>
+            <a:r>
+              <a:rPr lang="de-DE" sz="800" kern="0" dirty="0">
+                <a:solidFill>
+                  <a:prstClr val="black"/>
+                </a:solidFill>
+                <a:latin typeface="Calibri" panose="020F0502020204030204"/>
+              </a:rPr>
+              <a:t>= </a:t>
+            </a:r>
+            <a:r>
+              <a:rPr lang="de-DE" sz="800" kern="0" dirty="0" err="1">
+                <a:solidFill>
+                  <a:prstClr val="black"/>
+                </a:solidFill>
+                <a:latin typeface="Calibri" panose="020F0502020204030204"/>
+              </a:rPr>
+              <a:t>mediatorVmTemplateName</a:t>
+            </a:r>
+            <a:endParaRPr lang="de-DE" sz="800" kern="0" dirty="0">
+              <a:solidFill>
+                <a:prstClr val="black"/>
+              </a:solidFill>
+              <a:latin typeface="Calibri" panose="020F0502020204030204"/>
+            </a:endParaRPr>
+          </a:p>
+          <a:p>
+            <a:pPr defTabSz="914400"/>
+            <a:r>
+              <a:rPr lang="de-DE" sz="800" kern="0" dirty="0" err="1">
+                <a:solidFill>
+                  <a:prstClr val="black"/>
+                </a:solidFill>
+                <a:highlight>
+                  <a:srgbClr val="FFFF00"/>
+                </a:highlight>
+                <a:latin typeface="Calibri" panose="020F0502020204030204"/>
+              </a:rPr>
+              <a:t>defaultSnmpUserName</a:t>
+            </a:r>
+            <a:endParaRPr lang="de-DE" sz="800" kern="0" dirty="0">
+              <a:solidFill>
+                <a:prstClr val="black"/>
+              </a:solidFill>
+              <a:highlight>
+                <a:srgbClr val="FFFF00"/>
+              </a:highlight>
+              <a:latin typeface="Calibri" panose="020F0502020204030204"/>
+            </a:endParaRPr>
+          </a:p>
+          <a:p>
+            <a:pPr defTabSz="914400"/>
+            <a:r>
+              <a:rPr lang="de-DE" sz="800" kern="0">
+                <a:solidFill>
+                  <a:prstClr val="black"/>
+                </a:solidFill>
+                <a:highlight>
+                  <a:srgbClr val="FFFF00"/>
+                </a:highlight>
+                <a:latin typeface="Calibri" panose="020F0502020204030204"/>
+              </a:rPr>
+              <a:t>defaultSnmpUserPassword</a:t>
+            </a:r>
+            <a:endParaRPr lang="de-DE" sz="800" kern="0" dirty="0">
+              <a:solidFill>
+                <a:prstClr val="black"/>
+              </a:solidFill>
+              <a:highlight>
+                <a:srgbClr val="FFFF00"/>
+              </a:highlight>
+              <a:latin typeface="Calibri" panose="020F0502020204030204"/>
+            </a:endParaRPr>
+          </a:p>
+          <a:p>
+            <a:pPr defTabSz="914400"/>
+            <a:endParaRPr lang="de-DE" sz="800" kern="0" dirty="0">
+              <a:solidFill>
+                <a:prstClr val="black"/>
+              </a:solidFill>
+              <a:latin typeface="Calibri" panose="020F0502020204030204"/>
+            </a:endParaRPr>
+          </a:p>
         </p:txBody>
       </p:sp>
       <p:cxnSp>
@@ -5604,7 +5880,7 @@
         <p:spPr>
           <a:xfrm flipH="1">
             <a:off x="10141898" y="7583786"/>
-            <a:ext cx="674365" cy="52891"/>
+            <a:ext cx="674365" cy="159378"/>
           </a:xfrm>
           <a:prstGeom prst="straightConnector1">
             <a:avLst/>
@@ -5971,8 +6247,8 @@
         </p:nvSpPr>
         <p:spPr>
           <a:xfrm>
-            <a:off x="17566269" y="12736077"/>
-            <a:ext cx="1425832" cy="479569"/>
+            <a:off x="17566269" y="12369801"/>
+            <a:ext cx="1425832" cy="845846"/>
           </a:xfrm>
           <a:prstGeom prst="rect">
             <a:avLst/>
@@ -5997,38 +6273,140 @@
               <a:defRPr/>
             </a:pPr>
             <a:r>
-              <a:rPr lang="de-DE" sz="800" kern="0">
+              <a:rPr lang="de-DE" sz="800" kern="0" dirty="0" err="1">
                 <a:solidFill>
                   <a:prstClr val="black"/>
                 </a:solidFill>
                 <a:latin typeface="Calibri" panose="020F0502020204030204"/>
               </a:rPr>
-              <a:t>local-id=[mediatorUserName]</a:t>
+              <a:t>local-id</a:t>
+            </a:r>
+            <a:r>
+              <a:rPr lang="de-DE" sz="800" kern="0" dirty="0">
+                <a:solidFill>
+                  <a:prstClr val="black"/>
+                </a:solidFill>
+                <a:latin typeface="Calibri" panose="020F0502020204030204"/>
+              </a:rPr>
+              <a:t>=[</a:t>
+            </a:r>
+            <a:r>
+              <a:rPr lang="de-DE" sz="800" kern="0" dirty="0" err="1">
+                <a:solidFill>
+                  <a:prstClr val="black"/>
+                </a:solidFill>
+                <a:latin typeface="Calibri" panose="020F0502020204030204"/>
+              </a:rPr>
+              <a:t>mediatorUserName</a:t>
+            </a:r>
+            <a:r>
+              <a:rPr lang="de-DE" sz="800" kern="0" dirty="0">
+                <a:solidFill>
+                  <a:prstClr val="black"/>
+                </a:solidFill>
+                <a:latin typeface="Calibri" panose="020F0502020204030204"/>
+              </a:rPr>
+              <a:t>]</a:t>
             </a:r>
           </a:p>
           <a:p>
             <a:pPr defTabSz="914400"/>
             <a:r>
-              <a:rPr lang="de-DE" sz="800" kern="0">
+              <a:rPr lang="de-DE" sz="800" strike="sngStrike" kern="0" dirty="0" err="1">
                 <a:solidFill>
                   <a:prstClr val="black"/>
                 </a:solidFill>
+                <a:highlight>
+                  <a:srgbClr val="FFFF00"/>
+                </a:highlight>
                 <a:latin typeface="Calibri" panose="020F0502020204030204"/>
               </a:rPr>
               <a:t>mediatorUserName</a:t>
             </a:r>
+            <a:endParaRPr lang="de-DE" sz="800" strike="sngStrike" kern="0" dirty="0">
+              <a:solidFill>
+                <a:prstClr val="black"/>
+              </a:solidFill>
+              <a:highlight>
+                <a:srgbClr val="FFFF00"/>
+              </a:highlight>
+              <a:latin typeface="Calibri" panose="020F0502020204030204"/>
+            </a:endParaRPr>
           </a:p>
           <a:p>
             <a:pPr defTabSz="914400"/>
             <a:r>
-              <a:rPr lang="de-DE" sz="800" kern="0">
+              <a:rPr lang="de-DE" sz="800" strike="sngStrike" kern="0" dirty="0" err="1">
                 <a:solidFill>
                   <a:prstClr val="black"/>
                 </a:solidFill>
+                <a:highlight>
+                  <a:srgbClr val="FFFF00"/>
+                </a:highlight>
                 <a:latin typeface="Calibri" panose="020F0502020204030204"/>
               </a:rPr>
               <a:t>mediatorUserPassword</a:t>
             </a:r>
+            <a:endParaRPr lang="de-DE" sz="800" strike="sngStrike" kern="0" dirty="0">
+              <a:solidFill>
+                <a:prstClr val="black"/>
+              </a:solidFill>
+              <a:highlight>
+                <a:srgbClr val="FFFF00"/>
+              </a:highlight>
+              <a:latin typeface="Calibri" panose="020F0502020204030204"/>
+            </a:endParaRPr>
+          </a:p>
+          <a:p>
+            <a:pPr defTabSz="914400"/>
+            <a:r>
+              <a:rPr lang="de-DE" sz="800" kern="0" dirty="0" err="1">
+                <a:solidFill>
+                  <a:prstClr val="black"/>
+                </a:solidFill>
+                <a:highlight>
+                  <a:srgbClr val="FFFF00"/>
+                </a:highlight>
+                <a:latin typeface="Calibri" panose="020F0502020204030204"/>
+              </a:rPr>
+              <a:t>snmpUserName</a:t>
+            </a:r>
+            <a:endParaRPr lang="de-DE" sz="800" kern="0" dirty="0">
+              <a:solidFill>
+                <a:prstClr val="black"/>
+              </a:solidFill>
+              <a:highlight>
+                <a:srgbClr val="FFFF00"/>
+              </a:highlight>
+              <a:latin typeface="Calibri" panose="020F0502020204030204"/>
+            </a:endParaRPr>
+          </a:p>
+          <a:p>
+            <a:pPr defTabSz="914400"/>
+            <a:r>
+              <a:rPr lang="de-DE" sz="800" kern="0" dirty="0" err="1">
+                <a:solidFill>
+                  <a:prstClr val="black"/>
+                </a:solidFill>
+                <a:highlight>
+                  <a:srgbClr val="FFFF00"/>
+                </a:highlight>
+                <a:latin typeface="Calibri" panose="020F0502020204030204"/>
+              </a:rPr>
+              <a:t>snmpUserPassword</a:t>
+            </a:r>
+            <a:endParaRPr lang="de-DE" sz="800" kern="0" dirty="0">
+              <a:solidFill>
+                <a:prstClr val="black"/>
+              </a:solidFill>
+              <a:highlight>
+                <a:srgbClr val="FFFF00"/>
+              </a:highlight>
+              <a:latin typeface="Calibri" panose="020F0502020204030204"/>
+            </a:endParaRPr>
+          </a:p>
+          <a:p>
+            <a:pPr defTabSz="914400"/>
             <a:endParaRPr lang="de-DE" sz="800" kern="0" dirty="0">
               <a:solidFill>
                 <a:prstClr val="black"/>
@@ -6056,8 +6434,8 @@
         </p:nvCxnSpPr>
         <p:spPr>
           <a:xfrm flipH="1" flipV="1">
-            <a:off x="18992101" y="12975862"/>
-            <a:ext cx="573605" cy="14867"/>
+            <a:off x="18992101" y="12792724"/>
+            <a:ext cx="573605" cy="198005"/>
           </a:xfrm>
           <a:prstGeom prst="straightConnector1">
             <a:avLst/>
@@ -11467,6 +11845,57 @@
           <a:effectLst/>
         </p:spPr>
       </p:cxnSp>
+      <p:sp>
+        <p:nvSpPr>
+          <p:cNvPr id="8" name="Textfeld 7">
+            <a:extLst>
+              <a:ext uri="{FF2B5EF4-FFF2-40B4-BE49-F238E27FC236}">
+                <a16:creationId xmlns:a16="http://schemas.microsoft.com/office/drawing/2014/main" id="{46A024A9-BC8E-99B6-6F1B-23046812678D}"/>
+              </a:ext>
+            </a:extLst>
+          </p:cNvPr>
+          <p:cNvSpPr txBox="1"/>
+          <p:nvPr/>
+        </p:nvSpPr>
+        <p:spPr>
+          <a:xfrm>
+            <a:off x="409482" y="322952"/>
+            <a:ext cx="1903085" cy="1015663"/>
+          </a:xfrm>
+          <a:prstGeom prst="rect">
+            <a:avLst/>
+          </a:prstGeom>
+          <a:noFill/>
+        </p:spPr>
+        <p:txBody>
+          <a:bodyPr wrap="none" rtlCol="0">
+            <a:spAutoFit/>
+          </a:bodyPr>
+          <a:lstStyle/>
+          <a:p>
+            <a:r>
+              <a:rPr lang="en-US" sz="6000" b="1" dirty="0">
+                <a:solidFill>
+                  <a:schemeClr val="accent4">
+                    <a:lumMod val="75000"/>
+                  </a:schemeClr>
+                </a:solidFill>
+              </a:rPr>
+              <a:t>D</a:t>
+            </a:r>
+            <a:r>
+              <a:rPr lang="en-US" sz="6000" b="1" noProof="0" dirty="0">
+                <a:solidFill>
+                  <a:schemeClr val="accent4">
+                    <a:lumMod val="75000"/>
+                  </a:schemeClr>
+                </a:solidFill>
+              </a:rPr>
+              <a:t>DM</a:t>
+            </a:r>
+          </a:p>
+        </p:txBody>
+      </p:sp>
     </p:spTree>
     <p:extLst>
       <p:ext uri="{BB962C8B-B14F-4D97-AF65-F5344CB8AC3E}">

</xml_diff>